<commit_message>
feat: expand PPTX pitch decks to 10 comprehensive slides for UZB, RUS, and ENG with competitive matrix and GTM strategy
</commit_message>
<xml_diff>
--- a/dont_stop_investor_pitch_deck.pptx
+++ b/dont_stop_investor_pitch_deck.pptx
@@ -13,6 +13,8 @@
     <p:sldId id="261" r:id="rId12"/>
     <p:sldId id="262" r:id="rId13"/>
     <p:sldId id="263" r:id="rId14"/>
+    <p:sldId id="264" r:id="rId15"/>
+    <p:sldId id="265" r:id="rId16"/>
   </p:sldIdLst>
   <p:sldSz cx="12191695" cy="6858000" type="screen4x3"/>
   <p:notesSz cx="6858000" cy="9144000"/>
@@ -3105,14 +3107,170 @@
       <p:grpSpPr/>
       <p:sp>
         <p:nvSpPr>
-          <p:cNvPr id="2" name="Rounded Rectangle 1"/>
+          <p:cNvPr id="2" name="TextBox 1"/>
+          <p:cNvSpPr txBox="1"/>
+          <p:nvPr/>
+        </p:nvSpPr>
+        <p:spPr>
+          <a:xfrm>
+            <a:off x="731520" y="1645920"/>
+            <a:ext cx="10698480" cy="4114800"/>
+          </a:xfrm>
+          <a:prstGeom prst="rect">
+            <a:avLst/>
+          </a:prstGeom>
+          <a:noFill/>
+        </p:spPr>
+        <p:txBody>
+          <a:bodyPr wrap="square">
+            <a:spAutoFit/>
+          </a:bodyPr>
+          <a:lstStyle/>
+          <a:p>
+            <a:pPr>
+              <a:spcAft>
+                <a:spcPts val="1400"/>
+              </a:spcAft>
+              <a:defRPr sz="1300" b="1">
+                <a:solidFill>
+                  <a:srgbClr val="FFB800"/>
+                </a:solidFill>
+              </a:defRPr>
+            </a:pPr>
+            <a:r>
+              <a:t>PRE-SEED • $50 000 • ISHLAYDIGAN WEB ENGINE</a:t>
+            </a:r>
+          </a:p>
+          <a:p>
+            <a:pPr>
+              <a:spcAft>
+                <a:spcPts val="1000"/>
+              </a:spcAft>
+              <a:defRPr sz="5400" b="1">
+                <a:solidFill>
+                  <a:srgbClr val="21D8A0"/>
+                </a:solidFill>
+              </a:defRPr>
+            </a:pPr>
+            <a:r>
+              <a:t>DON'T STOP</a:t>
+            </a:r>
+          </a:p>
+          <a:p>
+            <a:pPr>
+              <a:spcAft>
+                <a:spcPts val="1000"/>
+              </a:spcAft>
+              <a:defRPr sz="2400" b="1">
+                <a:solidFill>
+                  <a:srgbClr val="FFFFFF"/>
+                </a:solidFill>
+              </a:defRPr>
+            </a:pPr>
+            <a:r>
+              <a:t>Shaharni o'yin maydoniga aylantiradigan hudud egallash va fitness platformasi</a:t>
+            </a:r>
+          </a:p>
+          <a:p>
+            <a:pPr>
+              <a:defRPr sz="1600">
+                <a:solidFill>
+                  <a:srgbClr val="A3B8B0"/>
+                </a:solidFill>
+              </a:defRPr>
+            </a:pPr>
+            <a:r>
+              <a:t>Yurish va yugurishni shahar miqyosidagi jamoaviy va taktikal o'yinga aylantiramiz.</a:t>
+            </a:r>
+          </a:p>
+        </p:txBody>
+      </p:sp>
+    </p:spTree>
+  </p:cSld>
+  <p:clrMapOvr>
+    <a:masterClrMapping/>
+  </p:clrMapOvr>
+</p:sld>
+</file>
+
+<file path=ppt/slides/slide10.xml><?xml version="1.0" encoding="utf-8"?>
+<p:sld xmlns:a="http://schemas.openxmlformats.org/drawingml/2006/main" xmlns:p="http://schemas.openxmlformats.org/presentationml/2006/main" xmlns:r="http://schemas.openxmlformats.org/officeDocument/2006/relationships">
+  <p:cSld>
+    <p:bg>
+      <p:bgPr>
+        <a:solidFill>
+          <a:srgbClr val="0B1512"/>
+        </a:solidFill>
+        <a:effectLst/>
+      </p:bgPr>
+    </p:bg>
+    <p:spTree>
+      <p:nvGrpSpPr>
+        <p:cNvPr id="1" name=""/>
+        <p:cNvGrpSpPr/>
+        <p:nvPr/>
+      </p:nvGrpSpPr>
+      <p:grpSpPr/>
+      <p:sp>
+        <p:nvSpPr>
+          <p:cNvPr id="2" name="TextBox 1"/>
+          <p:cNvSpPr txBox="1"/>
+          <p:nvPr/>
+        </p:nvSpPr>
+        <p:spPr>
+          <a:xfrm>
+            <a:off x="731520" y="365760"/>
+            <a:ext cx="10698480" cy="1005840"/>
+          </a:xfrm>
+          <a:prstGeom prst="rect">
+            <a:avLst/>
+          </a:prstGeom>
+          <a:noFill/>
+        </p:spPr>
+        <p:txBody>
+          <a:bodyPr wrap="square" lIns="0" tIns="0" rIns="0" bIns="0">
+            <a:spAutoFit/>
+          </a:bodyPr>
+          <a:lstStyle/>
+          <a:p>
+            <a:pPr>
+              <a:spcAft>
+                <a:spcPts val="400"/>
+              </a:spcAft>
+              <a:defRPr sz="1100" b="1">
+                <a:solidFill>
+                  <a:srgbClr val="21D8A0"/>
+                </a:solidFill>
+              </a:defRPr>
+            </a:pPr>
+            <a:r>
+              <a:t>DON'T STOP — INVESTOR PITCH DECK</a:t>
+            </a:r>
+          </a:p>
+          <a:p>
+            <a:pPr>
+              <a:defRPr sz="2600" b="1">
+                <a:solidFill>
+                  <a:srgbClr val="FFFFFF"/>
+                </a:solidFill>
+              </a:defRPr>
+            </a:pPr>
+            <a:r>
+              <a:t>Tayyor Texnologik Asos (Web Engine Ready)</a:t>
+            </a:r>
+          </a:p>
+        </p:txBody>
+      </p:sp>
+      <p:sp>
+        <p:nvSpPr>
+          <p:cNvPr id="3" name="Rounded Rectangle 2"/>
           <p:cNvSpPr/>
           <p:nvPr/>
         </p:nvSpPr>
         <p:spPr>
           <a:xfrm>
-            <a:off x="914400" y="1097280"/>
-            <a:ext cx="10362895" cy="4663440"/>
+            <a:off x="731520" y="1645920"/>
+            <a:ext cx="3291840" cy="4389120"/>
           </a:xfrm>
           <a:prstGeom prst="roundRect">
             <a:avLst/>
@@ -3150,14 +3308,14 @@
       </p:sp>
       <p:sp>
         <p:nvSpPr>
-          <p:cNvPr id="3" name="TextBox 2"/>
+          <p:cNvPr id="4" name="TextBox 3"/>
           <p:cNvSpPr txBox="1"/>
           <p:nvPr/>
         </p:nvSpPr>
         <p:spPr>
           <a:xfrm>
-            <a:off x="1463040" y="1645920"/>
-            <a:ext cx="9265615" cy="3657600"/>
+            <a:off x="868680" y="1783080"/>
+            <a:ext cx="3017520" cy="4114800"/>
           </a:xfrm>
           <a:prstGeom prst="rect">
             <a:avLst/>
@@ -3174,56 +3332,216 @@
               <a:spcAft>
                 <a:spcPts val="600"/>
               </a:spcAft>
-              <a:defRPr sz="4600" b="1">
+              <a:defRPr sz="1600" b="1">
                 <a:solidFill>
                   <a:srgbClr val="21D8A0"/>
                 </a:solidFill>
               </a:defRPr>
             </a:pPr>
             <a:r>
-              <a:t>DON'T STOP</a:t>
-            </a:r>
-          </a:p>
+              <a:t>ISHLAYDIGAN WEB ENGINE</a:t>
+            </a:r>
+          </a:p>
+          <a:p>
+            <a:pPr>
+              <a:defRPr sz="1300">
+                <a:solidFill>
+                  <a:srgbClr val="A3B8B0"/>
+                </a:solidFill>
+              </a:defRPr>
+            </a:pPr>
+            <a:r>
+              <a:t>FastAPI + PostGIS + MapLibre GL real-vaqtda GPS konturini hisoblaydi.</a:t>
+            </a:r>
+          </a:p>
+        </p:txBody>
+      </p:sp>
+      <p:sp>
+        <p:nvSpPr>
+          <p:cNvPr id="5" name="Rounded Rectangle 4"/>
+          <p:cNvSpPr/>
+          <p:nvPr/>
+        </p:nvSpPr>
+        <p:spPr>
+          <a:xfrm>
+            <a:off x="4389120" y="1645920"/>
+            <a:ext cx="3291840" cy="4389120"/>
+          </a:xfrm>
+          <a:prstGeom prst="roundRect">
+            <a:avLst/>
+          </a:prstGeom>
+          <a:solidFill>
+            <a:srgbClr val="12241E"/>
+          </a:solidFill>
+          <a:ln w="19050">
+            <a:solidFill>
+              <a:srgbClr val="00E5FF"/>
+            </a:solidFill>
+          </a:ln>
+        </p:spPr>
+        <p:style>
+          <a:lnRef idx="1">
+            <a:schemeClr val="accent1"/>
+          </a:lnRef>
+          <a:fillRef idx="3">
+            <a:schemeClr val="accent1"/>
+          </a:fillRef>
+          <a:effectRef idx="2">
+            <a:schemeClr val="accent1"/>
+          </a:effectRef>
+          <a:fontRef idx="minor">
+            <a:schemeClr val="lt1"/>
+          </a:fontRef>
+        </p:style>
+        <p:txBody>
+          <a:bodyPr rtlCol="0" anchor="ctr"/>
+          <a:lstStyle/>
+          <a:p>
+            <a:pPr algn="ctr"/>
+          </a:p>
+        </p:txBody>
+      </p:sp>
+      <p:sp>
+        <p:nvSpPr>
+          <p:cNvPr id="6" name="TextBox 5"/>
+          <p:cNvSpPr txBox="1"/>
+          <p:nvPr/>
+        </p:nvSpPr>
+        <p:spPr>
+          <a:xfrm>
+            <a:off x="4526280" y="1783080"/>
+            <a:ext cx="3017520" cy="4114800"/>
+          </a:xfrm>
+          <a:prstGeom prst="rect">
+            <a:avLst/>
+          </a:prstGeom>
+          <a:noFill/>
+        </p:spPr>
+        <p:txBody>
+          <a:bodyPr wrap="square">
+            <a:spAutoFit/>
+          </a:bodyPr>
+          <a:lstStyle/>
           <a:p>
             <a:pPr>
               <a:spcAft>
-                <a:spcPts val="2000"/>
+                <a:spcPts val="600"/>
               </a:spcAft>
-              <a:defRPr sz="1800" b="1">
-                <a:solidFill>
-                  <a:srgbClr val="FFFFFF"/>
-                </a:solidFill>
-              </a:defRPr>
-            </a:pPr>
-            <a:r>
-              <a:t>REAL-WORLD TERRITORY CAPTURE &amp; GAMIFIED FITNESS PLATFORM</a:t>
-            </a:r>
-          </a:p>
+              <a:defRPr sz="1600" b="1">
+                <a:solidFill>
+                  <a:srgbClr val="00E5FF"/>
+                </a:solidFill>
+              </a:defRPr>
+            </a:pPr>
+            <a:r>
+              <a:t>105 AVTOMATIK TEST</a:t>
+            </a:r>
+          </a:p>
+          <a:p>
+            <a:pPr>
+              <a:defRPr sz="1300">
+                <a:solidFill>
+                  <a:srgbClr val="A3B8B0"/>
+                </a:solidFill>
+              </a:defRPr>
+            </a:pPr>
+            <a:r>
+              <a:t>100% test qamrovi va toza production build.</a:t>
+            </a:r>
+          </a:p>
+        </p:txBody>
+      </p:sp>
+      <p:sp>
+        <p:nvSpPr>
+          <p:cNvPr id="7" name="Rounded Rectangle 6"/>
+          <p:cNvSpPr/>
+          <p:nvPr/>
+        </p:nvSpPr>
+        <p:spPr>
+          <a:xfrm>
+            <a:off x="8046720" y="1645920"/>
+            <a:ext cx="3291840" cy="4389120"/>
+          </a:xfrm>
+          <a:prstGeom prst="roundRect">
+            <a:avLst/>
+          </a:prstGeom>
+          <a:solidFill>
+            <a:srgbClr val="12241E"/>
+          </a:solidFill>
+          <a:ln w="19050">
+            <a:solidFill>
+              <a:srgbClr val="FFB800"/>
+            </a:solidFill>
+          </a:ln>
+        </p:spPr>
+        <p:style>
+          <a:lnRef idx="1">
+            <a:schemeClr val="accent1"/>
+          </a:lnRef>
+          <a:fillRef idx="3">
+            <a:schemeClr val="accent1"/>
+          </a:fillRef>
+          <a:effectRef idx="2">
+            <a:schemeClr val="accent1"/>
+          </a:effectRef>
+          <a:fontRef idx="minor">
+            <a:schemeClr val="lt1"/>
+          </a:fontRef>
+        </p:style>
+        <p:txBody>
+          <a:bodyPr rtlCol="0" anchor="ctr"/>
+          <a:lstStyle/>
+          <a:p>
+            <a:pPr algn="ctr"/>
+          </a:p>
+        </p:txBody>
+      </p:sp>
+      <p:sp>
+        <p:nvSpPr>
+          <p:cNvPr id="8" name="TextBox 7"/>
+          <p:cNvSpPr txBox="1"/>
+          <p:nvPr/>
+        </p:nvSpPr>
+        <p:spPr>
+          <a:xfrm>
+            <a:off x="8183880" y="1783080"/>
+            <a:ext cx="3017520" cy="4114800"/>
+          </a:xfrm>
+          <a:prstGeom prst="rect">
+            <a:avLst/>
+          </a:prstGeom>
+          <a:noFill/>
+        </p:spPr>
+        <p:txBody>
+          <a:bodyPr wrap="square">
+            <a:spAutoFit/>
+          </a:bodyPr>
+          <a:lstStyle/>
           <a:p>
             <a:pPr>
               <a:spcAft>
-                <a:spcPts val="3600"/>
+                <a:spcPts val="600"/>
               </a:spcAft>
-              <a:defRPr sz="1500">
+              <a:defRPr sz="1600" b="1">
+                <a:solidFill>
+                  <a:srgbClr val="FFB800"/>
+                </a:solidFill>
+              </a:defRPr>
+            </a:pPr>
+            <a:r>
+              <a:t>MOBILE PIPELINE</a:t>
+            </a:r>
+          </a:p>
+          <a:p>
+            <a:pPr>
+              <a:defRPr sz="1300">
                 <a:solidFill>
                   <a:srgbClr val="A3B8B0"/>
                 </a:solidFill>
               </a:defRPr>
             </a:pPr>
             <a:r>
-              <a:t>Turning daily walking and running into competitive guild territory control.</a:t>
-            </a:r>
-          </a:p>
-          <a:p>
-            <a:pPr>
-              <a:defRPr sz="1300" b="1">
-                <a:solidFill>
-                  <a:srgbClr val="FFB800"/>
-                </a:solidFill>
-              </a:defRPr>
-            </a:pPr>
-            <a:r>
-              <a:t>🎯 Target Funding Ask: $50,000 USD (Pre-Seed)   |   📍 Stage: Fully Built &amp; Test-Verified Web Engine</a:t>
+              <a:t>React + Vite + Capacitor orqali Android APK tayyor holatda.</a:t>
             </a:r>
           </a:p>
         </p:txBody>
@@ -3287,7 +3605,7 @@
               </a:defRPr>
             </a:pPr>
             <a:r>
-              <a:t>DON'T STOP — PITCH DECK</a:t>
+              <a:t>DON'T STOP — INVESTOR PITCH DECK</a:t>
             </a:r>
           </a:p>
           <a:p>
@@ -3299,7 +3617,7 @@
               </a:defRPr>
             </a:pPr>
             <a:r>
-              <a:t>The Problem &amp; Market Opportunity</a:t>
+              <a:t>Muammo va Bozor Imkoniyati</a:t>
             </a:r>
           </a:p>
         </p:txBody>
@@ -3312,155 +3630,8 @@
         </p:nvSpPr>
         <p:spPr>
           <a:xfrm>
-            <a:off x="731520" y="1554480"/>
-            <a:ext cx="5120640" cy="4663440"/>
-          </a:xfrm>
-          <a:prstGeom prst="roundRect">
-            <a:avLst/>
-          </a:prstGeom>
-          <a:solidFill>
-            <a:srgbClr val="12241E"/>
-          </a:solidFill>
-          <a:ln w="19050">
-            <a:solidFill>
-              <a:srgbClr val="FF3B30"/>
-            </a:solidFill>
-          </a:ln>
-        </p:spPr>
-        <p:style>
-          <a:lnRef idx="1">
-            <a:schemeClr val="accent1"/>
-          </a:lnRef>
-          <a:fillRef idx="3">
-            <a:schemeClr val="accent1"/>
-          </a:fillRef>
-          <a:effectRef idx="2">
-            <a:schemeClr val="accent1"/>
-          </a:effectRef>
-          <a:fontRef idx="minor">
-            <a:schemeClr val="lt1"/>
-          </a:fontRef>
-        </p:style>
-        <p:txBody>
-          <a:bodyPr rtlCol="0" anchor="ctr" wrap="square" lIns="274320" rIns="274320" tIns="274320"/>
-          <a:lstStyle/>
-          <a:p>
-            <a:pPr algn="ctr">
-              <a:spcAft>
-                <a:spcPts val="1400"/>
-              </a:spcAft>
-              <a:defRPr sz="1800" b="1">
-                <a:solidFill>
-                  <a:srgbClr val="FF3B30"/>
-                </a:solidFill>
-              </a:defRPr>
-            </a:pPr>
-            <a:r>
-              <a:t>⚠️ THE PROBLEM</a:t>
-            </a:r>
-          </a:p>
-          <a:p>
-            <a:pPr>
-              <a:spcAft>
-                <a:spcPts val="200"/>
-              </a:spcAft>
-              <a:defRPr sz="1300" b="1">
-                <a:solidFill>
-                  <a:srgbClr val="FFFFFF"/>
-                </a:solidFill>
-              </a:defRPr>
-            </a:pPr>
-            <a:r>
-              <a:t>• Boring Fitness Apps: </a:t>
-            </a:r>
-          </a:p>
-          <a:p>
-            <a:pPr>
-              <a:spcAft>
-                <a:spcPts val="1200"/>
-              </a:spcAft>
-              <a:defRPr sz="1200">
-                <a:solidFill>
-                  <a:srgbClr val="A3B8B0"/>
-                </a:solidFill>
-              </a:defRPr>
-            </a:pPr>
-            <a:r>
-              <a:t>  Traditional tracking apps (Strava, Nike Run) feel like work, leading to high 30-day user churn.</a:t>
-            </a:r>
-          </a:p>
-          <a:p>
-            <a:pPr>
-              <a:spcAft>
-                <a:spcPts val="200"/>
-              </a:spcAft>
-              <a:defRPr sz="1300" b="1">
-                <a:solidFill>
-                  <a:srgbClr val="FFFFFF"/>
-                </a:solidFill>
-              </a:defRPr>
-            </a:pPr>
-            <a:r>
-              <a:t>• Lack of Social Pride: </a:t>
-            </a:r>
-          </a:p>
-          <a:p>
-            <a:pPr>
-              <a:spcAft>
-                <a:spcPts val="1200"/>
-              </a:spcAft>
-              <a:defRPr sz="1200">
-                <a:solidFill>
-                  <a:srgbClr val="A3B8B0"/>
-                </a:solidFill>
-              </a:defRPr>
-            </a:pPr>
-            <a:r>
-              <a:t>  Users run alone without meaningful team goals or local territory control.</a:t>
-            </a:r>
-          </a:p>
-          <a:p>
-            <a:pPr>
-              <a:spcAft>
-                <a:spcPts val="200"/>
-              </a:spcAft>
-              <a:defRPr sz="1300" b="1">
-                <a:solidFill>
-                  <a:srgbClr val="FFFFFF"/>
-                </a:solidFill>
-              </a:defRPr>
-            </a:pPr>
-            <a:r>
-              <a:t>• Gamification Gap: </a:t>
-            </a:r>
-          </a:p>
-          <a:p>
-            <a:pPr>
-              <a:spcAft>
-                <a:spcPts val="1200"/>
-              </a:spcAft>
-              <a:defRPr sz="1200">
-                <a:solidFill>
-                  <a:srgbClr val="A3B8B0"/>
-                </a:solidFill>
-              </a:defRPr>
-            </a:pPr>
-            <a:r>
-              <a:t>  Mobile gamers want real-world movement mechanics, but existing apps lack deep guild systems.</a:t>
-            </a:r>
-          </a:p>
-        </p:txBody>
-      </p:sp>
-      <p:sp>
-        <p:nvSpPr>
-          <p:cNvPr id="4" name="Rounded Rectangle 3"/>
-          <p:cNvSpPr/>
-          <p:nvPr/>
-        </p:nvSpPr>
-        <p:spPr>
-          <a:xfrm>
-            <a:off x="6309360" y="1554480"/>
-            <a:ext cx="5120640" cy="4663440"/>
+            <a:off x="731520" y="1645920"/>
+            <a:ext cx="3291840" cy="4389120"/>
           </a:xfrm>
           <a:prstGeom prst="roundRect">
             <a:avLst/>
@@ -3489,111 +3660,249 @@
           </a:fontRef>
         </p:style>
         <p:txBody>
-          <a:bodyPr rtlCol="0" anchor="ctr" wrap="square" lIns="274320" rIns="274320" tIns="274320"/>
-          <a:lstStyle/>
-          <a:p>
-            <a:pPr algn="ctr">
+          <a:bodyPr rtlCol="0" anchor="ctr"/>
+          <a:lstStyle/>
+          <a:p>
+            <a:pPr algn="ctr"/>
+          </a:p>
+        </p:txBody>
+      </p:sp>
+      <p:sp>
+        <p:nvSpPr>
+          <p:cNvPr id="4" name="TextBox 3"/>
+          <p:cNvSpPr txBox="1"/>
+          <p:nvPr/>
+        </p:nvSpPr>
+        <p:spPr>
+          <a:xfrm>
+            <a:off x="868680" y="1783080"/>
+            <a:ext cx="3017520" cy="4114800"/>
+          </a:xfrm>
+          <a:prstGeom prst="rect">
+            <a:avLst/>
+          </a:prstGeom>
+          <a:noFill/>
+        </p:spPr>
+        <p:txBody>
+          <a:bodyPr wrap="square">
+            <a:spAutoFit/>
+          </a:bodyPr>
+          <a:lstStyle/>
+          <a:p>
+            <a:pPr>
               <a:spcAft>
-                <a:spcPts val="1400"/>
+                <a:spcPts val="600"/>
               </a:spcAft>
-              <a:defRPr sz="1800" b="1">
+              <a:defRPr sz="1600" b="1">
                 <a:solidFill>
                   <a:srgbClr val="21D8A0"/>
                 </a:solidFill>
               </a:defRPr>
             </a:pPr>
             <a:r>
-              <a:t>🚀 THE SOLUTION &amp; MARKET</a:t>
-            </a:r>
-          </a:p>
+              <a:t>01. Fitness Trekerlar Cheklovi</a:t>
+            </a:r>
+          </a:p>
+          <a:p>
+            <a:pPr>
+              <a:defRPr sz="1300">
+                <a:solidFill>
+                  <a:srgbClr val="A3B8B0"/>
+                </a:solidFill>
+              </a:defRPr>
+            </a:pPr>
+            <a:r>
+              <a:t>Strava va Nike faqat statistikani o'lchaydi, lekin kundalik harakatni jamoaviy o'yinga aylantirmaydi.</a:t>
+            </a:r>
+          </a:p>
+        </p:txBody>
+      </p:sp>
+      <p:sp>
+        <p:nvSpPr>
+          <p:cNvPr id="5" name="Rounded Rectangle 4"/>
+          <p:cNvSpPr/>
+          <p:nvPr/>
+        </p:nvSpPr>
+        <p:spPr>
+          <a:xfrm>
+            <a:off x="4389120" y="1645920"/>
+            <a:ext cx="3291840" cy="4389120"/>
+          </a:xfrm>
+          <a:prstGeom prst="roundRect">
+            <a:avLst/>
+          </a:prstGeom>
+          <a:solidFill>
+            <a:srgbClr val="12241E"/>
+          </a:solidFill>
+          <a:ln w="19050">
+            <a:solidFill>
+              <a:srgbClr val="21D8A0"/>
+            </a:solidFill>
+          </a:ln>
+        </p:spPr>
+        <p:style>
+          <a:lnRef idx="1">
+            <a:schemeClr val="accent1"/>
+          </a:lnRef>
+          <a:fillRef idx="3">
+            <a:schemeClr val="accent1"/>
+          </a:fillRef>
+          <a:effectRef idx="2">
+            <a:schemeClr val="accent1"/>
+          </a:effectRef>
+          <a:fontRef idx="minor">
+            <a:schemeClr val="lt1"/>
+          </a:fontRef>
+        </p:style>
+        <p:txBody>
+          <a:bodyPr rtlCol="0" anchor="ctr"/>
+          <a:lstStyle/>
+          <a:p>
+            <a:pPr algn="ctr"/>
+          </a:p>
+        </p:txBody>
+      </p:sp>
+      <p:sp>
+        <p:nvSpPr>
+          <p:cNvPr id="6" name="TextBox 5"/>
+          <p:cNvSpPr txBox="1"/>
+          <p:nvPr/>
+        </p:nvSpPr>
+        <p:spPr>
+          <a:xfrm>
+            <a:off x="4526280" y="1783080"/>
+            <a:ext cx="3017520" cy="4114800"/>
+          </a:xfrm>
+          <a:prstGeom prst="rect">
+            <a:avLst/>
+          </a:prstGeom>
+          <a:noFill/>
+        </p:spPr>
+        <p:txBody>
+          <a:bodyPr wrap="square">
+            <a:spAutoFit/>
+          </a:bodyPr>
+          <a:lstStyle/>
           <a:p>
             <a:pPr>
               <a:spcAft>
-                <a:spcPts val="200"/>
+                <a:spcPts val="600"/>
               </a:spcAft>
-              <a:defRPr sz="1300" b="1">
-                <a:solidFill>
-                  <a:srgbClr val="FFFFFF"/>
-                </a:solidFill>
-              </a:defRPr>
-            </a:pPr>
-            <a:r>
-              <a:t>✔ Gamified Fitness Turf Warfare: </a:t>
-            </a:r>
-          </a:p>
+              <a:defRPr sz="1600" b="1">
+                <a:solidFill>
+                  <a:srgbClr val="21D8A0"/>
+                </a:solidFill>
+              </a:defRPr>
+            </a:pPr>
+            <a:r>
+              <a:t>02. Yolg'izlik va Motivatsiya Yo'qligi</a:t>
+            </a:r>
+          </a:p>
+          <a:p>
+            <a:pPr>
+              <a:defRPr sz="1300">
+                <a:solidFill>
+                  <a:srgbClr val="A3B8B0"/>
+                </a:solidFill>
+              </a:defRPr>
+            </a:pPr>
+            <a:r>
+              <a:t>Ko'pchilik yuguruvchilar yolg'iz shug'ullanadi. Mahalliy raqobat va jamoaviy maqsad yetishmaydi.</a:t>
+            </a:r>
+          </a:p>
+        </p:txBody>
+      </p:sp>
+      <p:sp>
+        <p:nvSpPr>
+          <p:cNvPr id="7" name="Rounded Rectangle 6"/>
+          <p:cNvSpPr/>
+          <p:nvPr/>
+        </p:nvSpPr>
+        <p:spPr>
+          <a:xfrm>
+            <a:off x="8046720" y="1645920"/>
+            <a:ext cx="3291840" cy="4389120"/>
+          </a:xfrm>
+          <a:prstGeom prst="roundRect">
+            <a:avLst/>
+          </a:prstGeom>
+          <a:solidFill>
+            <a:srgbClr val="12241E"/>
+          </a:solidFill>
+          <a:ln w="19050">
+            <a:solidFill>
+              <a:srgbClr val="21D8A0"/>
+            </a:solidFill>
+          </a:ln>
+        </p:spPr>
+        <p:style>
+          <a:lnRef idx="1">
+            <a:schemeClr val="accent1"/>
+          </a:lnRef>
+          <a:fillRef idx="3">
+            <a:schemeClr val="accent1"/>
+          </a:fillRef>
+          <a:effectRef idx="2">
+            <a:schemeClr val="accent1"/>
+          </a:effectRef>
+          <a:fontRef idx="minor">
+            <a:schemeClr val="lt1"/>
+          </a:fontRef>
+        </p:style>
+        <p:txBody>
+          <a:bodyPr rtlCol="0" anchor="ctr"/>
+          <a:lstStyle/>
+          <a:p>
+            <a:pPr algn="ctr"/>
+          </a:p>
+        </p:txBody>
+      </p:sp>
+      <p:sp>
+        <p:nvSpPr>
+          <p:cNvPr id="8" name="TextBox 7"/>
+          <p:cNvSpPr txBox="1"/>
+          <p:nvPr/>
+        </p:nvSpPr>
+        <p:spPr>
+          <a:xfrm>
+            <a:off x="8183880" y="1783080"/>
+            <a:ext cx="3017520" cy="4114800"/>
+          </a:xfrm>
+          <a:prstGeom prst="rect">
+            <a:avLst/>
+          </a:prstGeom>
+          <a:noFill/>
+        </p:spPr>
+        <p:txBody>
+          <a:bodyPr wrap="square">
+            <a:spAutoFit/>
+          </a:bodyPr>
+          <a:lstStyle/>
           <a:p>
             <a:pPr>
               <a:spcAft>
-                <a:spcPts val="1200"/>
+                <a:spcPts val="600"/>
               </a:spcAft>
-              <a:defRPr sz="1200">
+              <a:defRPr sz="1600" b="1">
+                <a:solidFill>
+                  <a:srgbClr val="21D8A0"/>
+                </a:solidFill>
+              </a:defRPr>
+            </a:pPr>
+            <a:r>
+              <a:t>03. Chuqur Guild Mexanikasi Yo'qligi</a:t>
+            </a:r>
+          </a:p>
+          <a:p>
+            <a:pPr>
+              <a:defRPr sz="1300">
                 <a:solidFill>
                   <a:srgbClr val="A3B8B0"/>
                 </a:solidFill>
               </a:defRPr>
             </a:pPr>
             <a:r>
-              <a:t>  Walk or run in closed loops to capture city ground on interactive live maps.</a:t>
-            </a:r>
-          </a:p>
-          <a:p>
-            <a:pPr>
-              <a:spcAft>
-                <a:spcPts val="200"/>
-              </a:spcAft>
-              <a:defRPr sz="1300" b="1">
-                <a:solidFill>
-                  <a:srgbClr val="FFFFFF"/>
-                </a:solidFill>
-              </a:defRPr>
-            </a:pPr>
-            <a:r>
-              <a:t>✔ Guild Power &amp; Social Rivalry: </a:t>
-            </a:r>
-          </a:p>
-          <a:p>
-            <a:pPr>
-              <a:spcAft>
-                <a:spcPts val="1200"/>
-              </a:spcAft>
-              <a:defRPr sz="1200">
-                <a:solidFill>
-                  <a:srgbClr val="A3B8B0"/>
-                </a:solidFill>
-              </a:defRPr>
-            </a:pPr>
-            <a:r>
-              <a:t>  Form 10-member Guilds with custom Vector Emblems, tags, and team tactics.</a:t>
-            </a:r>
-          </a:p>
-          <a:p>
-            <a:pPr>
-              <a:spcAft>
-                <a:spcPts val="200"/>
-              </a:spcAft>
-              <a:defRPr sz="1300" b="1">
-                <a:solidFill>
-                  <a:srgbClr val="FFFFFF"/>
-                </a:solidFill>
-              </a:defRPr>
-            </a:pPr>
-            <a:r>
-              <a:t>✔ Massive Market Potential: </a:t>
-            </a:r>
-          </a:p>
-          <a:p>
-            <a:pPr>
-              <a:spcAft>
-                <a:spcPts val="1200"/>
-              </a:spcAft>
-              <a:defRPr sz="1200">
-                <a:solidFill>
-                  <a:srgbClr val="A3B8B0"/>
-                </a:solidFill>
-              </a:defRPr>
-            </a:pPr>
-            <a:r>
-              <a:t>  Crossing the $14B Move-to-Earn / Gamified Fitness &amp; $180B Mobile Gaming markets.</a:t>
+              <a:t>Mobil o'yinchilar real dunyoda progressni xohlaydi, mavjud o'yinlarda esa real GPS hudud warfare yo'q.</a:t>
             </a:r>
           </a:p>
         </p:txBody>
@@ -3657,7 +3966,7 @@
               </a:defRPr>
             </a:pPr>
             <a:r>
-              <a:t>DON'T STOP — PITCH DECK</a:t>
+              <a:t>DON'T STOP — INVESTOR PITCH DECK</a:t>
             </a:r>
           </a:p>
           <a:p>
@@ -3669,7 +3978,7 @@
               </a:defRPr>
             </a:pPr>
             <a:r>
-              <a:t>Core Product Architecture &amp; Key Features</a:t>
+              <a:t>Mahsulot Qanday Ishlaydi?</a:t>
             </a:r>
           </a:p>
         </p:txBody>
@@ -3683,7 +3992,7 @@
         <p:spPr>
           <a:xfrm>
             <a:off x="731520" y="1645920"/>
-            <a:ext cx="5120640" cy="1463040"/>
+            <a:ext cx="3291840" cy="4389120"/>
           </a:xfrm>
           <a:prstGeom prst="roundRect">
             <a:avLst/>
@@ -3691,9 +4000,9 @@
           <a:solidFill>
             <a:srgbClr val="12241E"/>
           </a:solidFill>
-          <a:ln w="15240">
+          <a:ln w="19050">
             <a:solidFill>
-              <a:srgbClr val="21D8A0"/>
+              <a:srgbClr val="00E5FF"/>
             </a:solidFill>
           </a:ln>
         </p:spPr>
@@ -3712,47 +4021,73 @@
           </a:fontRef>
         </p:style>
         <p:txBody>
-          <a:bodyPr rtlCol="0" anchor="ctr" wrap="square" lIns="182880" rIns="182880" tIns="182880"/>
-          <a:lstStyle/>
-          <a:p>
-            <a:pPr algn="ctr">
+          <a:bodyPr rtlCol="0" anchor="ctr"/>
+          <a:lstStyle/>
+          <a:p>
+            <a:pPr algn="ctr"/>
+          </a:p>
+        </p:txBody>
+      </p:sp>
+      <p:sp>
+        <p:nvSpPr>
+          <p:cNvPr id="4" name="TextBox 3"/>
+          <p:cNvSpPr txBox="1"/>
+          <p:nvPr/>
+        </p:nvSpPr>
+        <p:spPr>
+          <a:xfrm>
+            <a:off x="868680" y="1783080"/>
+            <a:ext cx="3017520" cy="4114800"/>
+          </a:xfrm>
+          <a:prstGeom prst="rect">
+            <a:avLst/>
+          </a:prstGeom>
+          <a:noFill/>
+        </p:spPr>
+        <p:txBody>
+          <a:bodyPr wrap="square">
+            <a:spAutoFit/>
+          </a:bodyPr>
+          <a:lstStyle/>
+          <a:p>
+            <a:pPr>
               <a:spcAft>
-                <a:spcPts val="400"/>
+                <a:spcPts val="600"/>
               </a:spcAft>
-              <a:defRPr sz="1500" b="1">
-                <a:solidFill>
-                  <a:srgbClr val="FFFFFF"/>
-                </a:solidFill>
-              </a:defRPr>
-            </a:pPr>
-            <a:r>
-              <a:t>📍 Closed-Loop GPS Tracking</a:t>
-            </a:r>
-          </a:p>
-          <a:p>
-            <a:pPr>
-              <a:defRPr sz="1200">
+              <a:defRPr sz="1600" b="1">
+                <a:solidFill>
+                  <a:srgbClr val="00E5FF"/>
+                </a:solidFill>
+              </a:defRPr>
+            </a:pPr>
+            <a:r>
+              <a:t>1. MARSHRUT</a:t>
+            </a:r>
+          </a:p>
+          <a:p>
+            <a:pPr>
+              <a:defRPr sz="1300">
                 <a:solidFill>
                   <a:srgbClr val="A3B8B0"/>
                 </a:solidFill>
               </a:defRPr>
             </a:pPr>
             <a:r>
-              <a:t>Real-time vector loop preview &amp; connection gap calculation via high-precision Kalman filtering.</a:t>
-            </a:r>
-          </a:p>
-        </p:txBody>
-      </p:sp>
-      <p:sp>
-        <p:nvSpPr>
-          <p:cNvPr id="4" name="Rounded Rectangle 3"/>
+              <a:t>GPS yopiq kontur va ulanish masofasini real-vaqtda tekshiradi.</a:t>
+            </a:r>
+          </a:p>
+        </p:txBody>
+      </p:sp>
+      <p:sp>
+        <p:nvSpPr>
+          <p:cNvPr id="5" name="Rounded Rectangle 4"/>
           <p:cNvSpPr/>
           <p:nvPr/>
         </p:nvSpPr>
         <p:spPr>
           <a:xfrm>
-            <a:off x="6309360" y="1645920"/>
-            <a:ext cx="5120640" cy="1463040"/>
+            <a:off x="4389120" y="1645920"/>
+            <a:ext cx="3291840" cy="4389120"/>
           </a:xfrm>
           <a:prstGeom prst="roundRect">
             <a:avLst/>
@@ -3760,9 +4095,9 @@
           <a:solidFill>
             <a:srgbClr val="12241E"/>
           </a:solidFill>
-          <a:ln w="15240">
+          <a:ln w="19050">
             <a:solidFill>
-              <a:srgbClr val="00E5FF"/>
+              <a:srgbClr val="FFB800"/>
             </a:solidFill>
           </a:ln>
         </p:spPr>
@@ -3781,47 +4116,73 @@
           </a:fontRef>
         </p:style>
         <p:txBody>
-          <a:bodyPr rtlCol="0" anchor="ctr" wrap="square" lIns="182880" rIns="182880" tIns="182880"/>
-          <a:lstStyle/>
-          <a:p>
-            <a:pPr algn="ctr">
+          <a:bodyPr rtlCol="0" anchor="ctr"/>
+          <a:lstStyle/>
+          <a:p>
+            <a:pPr algn="ctr"/>
+          </a:p>
+        </p:txBody>
+      </p:sp>
+      <p:sp>
+        <p:nvSpPr>
+          <p:cNvPr id="6" name="TextBox 5"/>
+          <p:cNvSpPr txBox="1"/>
+          <p:nvPr/>
+        </p:nvSpPr>
+        <p:spPr>
+          <a:xfrm>
+            <a:off x="4526280" y="1783080"/>
+            <a:ext cx="3017520" cy="4114800"/>
+          </a:xfrm>
+          <a:prstGeom prst="rect">
+            <a:avLst/>
+          </a:prstGeom>
+          <a:noFill/>
+        </p:spPr>
+        <p:txBody>
+          <a:bodyPr wrap="square">
+            <a:spAutoFit/>
+          </a:bodyPr>
+          <a:lstStyle/>
+          <a:p>
+            <a:pPr>
               <a:spcAft>
-                <a:spcPts val="400"/>
+                <a:spcPts val="600"/>
               </a:spcAft>
-              <a:defRPr sz="1500" b="1">
-                <a:solidFill>
-                  <a:srgbClr val="FFFFFF"/>
-                </a:solidFill>
-              </a:defRPr>
-            </a:pPr>
-            <a:r>
-              <a:t>🛡️ 10-Member Guild System</a:t>
-            </a:r>
-          </a:p>
-          <a:p>
-            <a:pPr>
-              <a:defRPr sz="1200">
+              <a:defRPr sz="1600" b="1">
+                <a:solidFill>
+                  <a:srgbClr val="FFB800"/>
+                </a:solidFill>
+              </a:defRPr>
+            </a:pPr>
+            <a:r>
+              <a:t>2. HUDUD</a:t>
+            </a:r>
+          </a:p>
+          <a:p>
+            <a:pPr>
+              <a:defRPr sz="1300">
                 <a:solidFill>
                   <a:srgbClr val="A3B8B0"/>
                 </a:solidFill>
               </a:defRPr>
             </a:pPr>
             <a:r>
-              <a:t>Custom Vector Emblems (Shield, Swords, Crown, Zap, Flame, Trophy, Gem, Target, Citadel, Skull).</a:t>
-            </a:r>
-          </a:p>
-        </p:txBody>
-      </p:sp>
-      <p:sp>
-        <p:nvSpPr>
-          <p:cNvPr id="5" name="Rounded Rectangle 4"/>
+              <a:t>Tasdiqlangan kontur ichidagi maydon PostGIS yordamida egallanadi.</a:t>
+            </a:r>
+          </a:p>
+        </p:txBody>
+      </p:sp>
+      <p:sp>
+        <p:nvSpPr>
+          <p:cNvPr id="7" name="Rounded Rectangle 6"/>
           <p:cNvSpPr/>
           <p:nvPr/>
         </p:nvSpPr>
         <p:spPr>
           <a:xfrm>
-            <a:off x="731520" y="3291840"/>
-            <a:ext cx="5120640" cy="1463040"/>
+            <a:off x="8046720" y="1645920"/>
+            <a:ext cx="3291840" cy="4389120"/>
           </a:xfrm>
           <a:prstGeom prst="roundRect">
             <a:avLst/>
@@ -3829,7 +4190,7 @@
           <a:solidFill>
             <a:srgbClr val="12241E"/>
           </a:solidFill>
-          <a:ln w="15240">
+          <a:ln w="19050">
             <a:solidFill>
               <a:srgbClr val="21D8A0"/>
             </a:solidFill>
@@ -3850,171 +4211,59 @@
           </a:fontRef>
         </p:style>
         <p:txBody>
-          <a:bodyPr rtlCol="0" anchor="ctr" wrap="square" lIns="182880" rIns="182880" tIns="182880"/>
-          <a:lstStyle/>
-          <a:p>
-            <a:pPr algn="ctr">
+          <a:bodyPr rtlCol="0" anchor="ctr"/>
+          <a:lstStyle/>
+          <a:p>
+            <a:pPr algn="ctr"/>
+          </a:p>
+        </p:txBody>
+      </p:sp>
+      <p:sp>
+        <p:nvSpPr>
+          <p:cNvPr id="8" name="TextBox 7"/>
+          <p:cNvSpPr txBox="1"/>
+          <p:nvPr/>
+        </p:nvSpPr>
+        <p:spPr>
+          <a:xfrm>
+            <a:off x="8183880" y="1783080"/>
+            <a:ext cx="3017520" cy="4114800"/>
+          </a:xfrm>
+          <a:prstGeom prst="rect">
+            <a:avLst/>
+          </a:prstGeom>
+          <a:noFill/>
+        </p:spPr>
+        <p:txBody>
+          <a:bodyPr wrap="square">
+            <a:spAutoFit/>
+          </a:bodyPr>
+          <a:lstStyle/>
+          <a:p>
+            <a:pPr>
               <a:spcAft>
-                <a:spcPts val="400"/>
+                <a:spcPts val="600"/>
               </a:spcAft>
-              <a:defRPr sz="1500" b="1">
-                <a:solidFill>
-                  <a:srgbClr val="FFB800"/>
-                </a:solidFill>
-              </a:defRPr>
-            </a:pPr>
-            <a:r>
-              <a:t>🔒 Privacy &amp; Anti-Cheat</a:t>
-            </a:r>
-          </a:p>
-          <a:p>
-            <a:pPr>
-              <a:defRPr sz="1200">
+              <a:defRPr sz="1600" b="1">
+                <a:solidFill>
+                  <a:srgbClr val="21D8A0"/>
+                </a:solidFill>
+              </a:defRPr>
+            </a:pPr>
+            <a:r>
+              <a:t>3. GILDIYA</a:t>
+            </a:r>
+          </a:p>
+          <a:p>
+            <a:pPr>
+              <a:defRPr sz="1300">
                 <a:solidFill>
                   <a:srgbClr val="A3B8B0"/>
                 </a:solidFill>
               </a:defRPr>
             </a:pPr>
             <a:r>
-              <a:t>200m Privacy Radius hide-home protection, PostGIS spatial exclusions (schools/buildings), teleport detection.</a:t>
-            </a:r>
-          </a:p>
-        </p:txBody>
-      </p:sp>
-      <p:sp>
-        <p:nvSpPr>
-          <p:cNvPr id="6" name="Rounded Rectangle 5"/>
-          <p:cNvSpPr/>
-          <p:nvPr/>
-        </p:nvSpPr>
-        <p:spPr>
-          <a:xfrm>
-            <a:off x="6309360" y="3291840"/>
-            <a:ext cx="5120640" cy="1463040"/>
-          </a:xfrm>
-          <a:prstGeom prst="roundRect">
-            <a:avLst/>
-          </a:prstGeom>
-          <a:solidFill>
-            <a:srgbClr val="12241E"/>
-          </a:solidFill>
-          <a:ln w="15240">
-            <a:solidFill>
-              <a:srgbClr val="00E5FF"/>
-            </a:solidFill>
-          </a:ln>
-        </p:spPr>
-        <p:style>
-          <a:lnRef idx="1">
-            <a:schemeClr val="accent1"/>
-          </a:lnRef>
-          <a:fillRef idx="3">
-            <a:schemeClr val="accent1"/>
-          </a:fillRef>
-          <a:effectRef idx="2">
-            <a:schemeClr val="accent1"/>
-          </a:effectRef>
-          <a:fontRef idx="minor">
-            <a:schemeClr val="lt1"/>
-          </a:fontRef>
-        </p:style>
-        <p:txBody>
-          <a:bodyPr rtlCol="0" anchor="ctr" wrap="square" lIns="182880" rIns="182880" tIns="182880"/>
-          <a:lstStyle/>
-          <a:p>
-            <a:pPr algn="ctr">
-              <a:spcAft>
-                <a:spcPts val="400"/>
-              </a:spcAft>
-              <a:defRPr sz="1500" b="1">
-                <a:solidFill>
-                  <a:srgbClr val="FFFFFF"/>
-                </a:solidFill>
-              </a:defRPr>
-            </a:pPr>
-            <a:r>
-              <a:t>🌐 5-Language Engine</a:t>
-            </a:r>
-          </a:p>
-          <a:p>
-            <a:pPr>
-              <a:defRPr sz="1200">
-                <a:solidFill>
-                  <a:srgbClr val="A3B8B0"/>
-                </a:solidFill>
-              </a:defRPr>
-            </a:pPr>
-            <a:r>
-              <a:t>Full localization in Karakalpak (qq), Uzbek (uz), Kazakh (kk), Turkish (tr), and English (en).</a:t>
-            </a:r>
-          </a:p>
-        </p:txBody>
-      </p:sp>
-      <p:sp>
-        <p:nvSpPr>
-          <p:cNvPr id="7" name="Rounded Rectangle 6"/>
-          <p:cNvSpPr/>
-          <p:nvPr/>
-        </p:nvSpPr>
-        <p:spPr>
-          <a:xfrm>
-            <a:off x="731520" y="5029200"/>
-            <a:ext cx="10698480" cy="1188720"/>
-          </a:xfrm>
-          <a:prstGeom prst="roundRect">
-            <a:avLst/>
-          </a:prstGeom>
-          <a:solidFill>
-            <a:srgbClr val="12241E"/>
-          </a:solidFill>
-          <a:ln w="15240">
-            <a:solidFill>
-              <a:srgbClr val="21D8A0"/>
-            </a:solidFill>
-          </a:ln>
-        </p:spPr>
-        <p:style>
-          <a:lnRef idx="1">
-            <a:schemeClr val="accent1"/>
-          </a:lnRef>
-          <a:fillRef idx="3">
-            <a:schemeClr val="accent1"/>
-          </a:fillRef>
-          <a:effectRef idx="2">
-            <a:schemeClr val="accent1"/>
-          </a:effectRef>
-          <a:fontRef idx="minor">
-            <a:schemeClr val="lt1"/>
-          </a:fontRef>
-        </p:style>
-        <p:txBody>
-          <a:bodyPr rtlCol="0" anchor="ctr" wrap="square" lIns="182880" rIns="182880" tIns="182880"/>
-          <a:lstStyle/>
-          <a:p>
-            <a:pPr algn="ctr">
-              <a:spcAft>
-                <a:spcPts val="400"/>
-              </a:spcAft>
-              <a:defRPr sz="1500" b="1">
-                <a:solidFill>
-                  <a:srgbClr val="FFFFFF"/>
-                </a:solidFill>
-              </a:defRPr>
-            </a:pPr>
-            <a:r>
-              <a:t>⚡ High Performance Stack</a:t>
-            </a:r>
-          </a:p>
-          <a:p>
-            <a:pPr>
-              <a:defRPr sz="1200">
-                <a:solidFill>
-                  <a:srgbClr val="A3B8B0"/>
-                </a:solidFill>
-              </a:defRPr>
-            </a:pPr>
-            <a:r>
-              <a:t>FastAPI Python backend + PostGIS spatial DB + Redis + MapLibre GL vector rendering.</a:t>
+              <a:t>Jamoa hududni himoya qiladi va haftalik reytingda ochko to'playdi.</a:t>
             </a:r>
           </a:p>
         </p:txBody>
@@ -4078,7 +4327,7 @@
               </a:defRPr>
             </a:pPr>
             <a:r>
-              <a:t>DON'T STOP — PITCH DECK</a:t>
+              <a:t>DON'T STOP — INVESTOR PITCH DECK</a:t>
             </a:r>
           </a:p>
           <a:p>
@@ -4090,7 +4339,7 @@
               </a:defRPr>
             </a:pPr>
             <a:r>
-              <a:t>Monetization Strategy &amp; Revenue Streams</a:t>
+              <a:t>Gildiya Janglari va Vektor Gerblar</a:t>
             </a:r>
           </a:p>
         </p:txBody>
@@ -4104,7 +4353,7 @@
         <p:spPr>
           <a:xfrm>
             <a:off x="731520" y="1645920"/>
-            <a:ext cx="5120640" cy="2103120"/>
+            <a:ext cx="5120640" cy="4389120"/>
           </a:xfrm>
           <a:prstGeom prst="roundRect">
             <a:avLst/>
@@ -4133,21 +4382,47 @@
           </a:fontRef>
         </p:style>
         <p:txBody>
-          <a:bodyPr rtlCol="0" anchor="ctr" wrap="square" lIns="228600" rIns="228600" tIns="228600"/>
-          <a:lstStyle/>
-          <a:p>
-            <a:pPr algn="ctr">
+          <a:bodyPr rtlCol="0" anchor="ctr"/>
+          <a:lstStyle/>
+          <a:p>
+            <a:pPr algn="ctr"/>
+          </a:p>
+        </p:txBody>
+      </p:sp>
+      <p:sp>
+        <p:nvSpPr>
+          <p:cNvPr id="4" name="TextBox 3"/>
+          <p:cNvSpPr txBox="1"/>
+          <p:nvPr/>
+        </p:nvSpPr>
+        <p:spPr>
+          <a:xfrm>
+            <a:off x="868680" y="1783080"/>
+            <a:ext cx="4846320" cy="4114800"/>
+          </a:xfrm>
+          <a:prstGeom prst="rect">
+            <a:avLst/>
+          </a:prstGeom>
+          <a:noFill/>
+        </p:spPr>
+        <p:txBody>
+          <a:bodyPr wrap="square">
+            <a:spAutoFit/>
+          </a:bodyPr>
+          <a:lstStyle/>
+          <a:p>
+            <a:pPr>
               <a:spcAft>
-                <a:spcPts val="800"/>
+                <a:spcPts val="600"/>
               </a:spcAft>
               <a:defRPr sz="1600" b="1">
                 <a:solidFill>
-                  <a:srgbClr val="21D8A0"/>
-                </a:solidFill>
-              </a:defRPr>
-            </a:pPr>
-            <a:r>
-              <a:t>🎟️ Seasonal Battle Pass</a:t>
+                  <a:srgbClr val="FFB800"/>
+                </a:solidFill>
+              </a:defRPr>
+            </a:pPr>
+            <a:r>
+              <a:t>10 Kishilik Gildiyalar</a:t>
             </a:r>
           </a:p>
           <a:p>
@@ -4159,21 +4434,21 @@
               </a:defRPr>
             </a:pPr>
             <a:r>
-              <a:t>Cosmetic territory trail effects, exclusive Guild Emblems, custom map color themes ($4.99/mo).</a:t>
-            </a:r>
-          </a:p>
-        </p:txBody>
-      </p:sp>
-      <p:sp>
-        <p:nvSpPr>
-          <p:cNvPr id="4" name="Rounded Rectangle 3"/>
+              <a:t>Do'stlar bilan jamoa tuzing va unique teg ([TAG]) bilan shahar yetakchisiga aylaning.</a:t>
+            </a:r>
+          </a:p>
+        </p:txBody>
+      </p:sp>
+      <p:sp>
+        <p:nvSpPr>
+          <p:cNvPr id="5" name="Rounded Rectangle 4"/>
           <p:cNvSpPr/>
           <p:nvPr/>
         </p:nvSpPr>
         <p:spPr>
           <a:xfrm>
-            <a:off x="6309359" y="1645920"/>
-            <a:ext cx="5120640" cy="2103120"/>
+            <a:off x="6217920" y="1645920"/>
+            <a:ext cx="5120640" cy="4389120"/>
           </a:xfrm>
           <a:prstGeom prst="roundRect">
             <a:avLst/>
@@ -4202,21 +4477,47 @@
           </a:fontRef>
         </p:style>
         <p:txBody>
-          <a:bodyPr rtlCol="0" anchor="ctr" wrap="square" lIns="228600" rIns="228600" tIns="228600"/>
-          <a:lstStyle/>
-          <a:p>
-            <a:pPr algn="ctr">
+          <a:bodyPr rtlCol="0" anchor="ctr"/>
+          <a:lstStyle/>
+          <a:p>
+            <a:pPr algn="ctr"/>
+          </a:p>
+        </p:txBody>
+      </p:sp>
+      <p:sp>
+        <p:nvSpPr>
+          <p:cNvPr id="6" name="TextBox 5"/>
+          <p:cNvSpPr txBox="1"/>
+          <p:nvPr/>
+        </p:nvSpPr>
+        <p:spPr>
+          <a:xfrm>
+            <a:off x="6355080" y="1783080"/>
+            <a:ext cx="4846320" cy="4114800"/>
+          </a:xfrm>
+          <a:prstGeom prst="rect">
+            <a:avLst/>
+          </a:prstGeom>
+          <a:noFill/>
+        </p:spPr>
+        <p:txBody>
+          <a:bodyPr wrap="square">
+            <a:spAutoFit/>
+          </a:bodyPr>
+          <a:lstStyle/>
+          <a:p>
+            <a:pPr>
               <a:spcAft>
-                <a:spcPts val="800"/>
+                <a:spcPts val="600"/>
               </a:spcAft>
               <a:defRPr sz="1600" b="1">
                 <a:solidFill>
-                  <a:srgbClr val="FFB800"/>
-                </a:solidFill>
-              </a:defRPr>
-            </a:pPr>
-            <a:r>
-              <a:t>🏢 B2B Brand Sponsorships</a:t>
+                  <a:srgbClr val="21D8A0"/>
+                </a:solidFill>
+              </a:defRPr>
+            </a:pPr>
+            <a:r>
+              <a:t>10 Eksklyuziv Gerb</a:t>
             </a:r>
           </a:p>
           <a:p>
@@ -4228,145 +4529,7 @@
               </a:defRPr>
             </a:pPr>
             <a:r>
-              <a:t>Local brands sponsor 2x Territory Events, branded capture zones, and sponsored tournaments ($2K–$10K/event).</a:t>
-            </a:r>
-          </a:p>
-        </p:txBody>
-      </p:sp>
-      <p:sp>
-        <p:nvSpPr>
-          <p:cNvPr id="5" name="Rounded Rectangle 4"/>
-          <p:cNvSpPr/>
-          <p:nvPr/>
-        </p:nvSpPr>
-        <p:spPr>
-          <a:xfrm>
-            <a:off x="731520" y="4023360"/>
-            <a:ext cx="5120640" cy="2103120"/>
-          </a:xfrm>
-          <a:prstGeom prst="roundRect">
-            <a:avLst/>
-          </a:prstGeom>
-          <a:solidFill>
-            <a:srgbClr val="12241E"/>
-          </a:solidFill>
-          <a:ln w="19050">
-            <a:solidFill>
-              <a:srgbClr val="21D8A0"/>
-            </a:solidFill>
-          </a:ln>
-        </p:spPr>
-        <p:style>
-          <a:lnRef idx="1">
-            <a:schemeClr val="accent1"/>
-          </a:lnRef>
-          <a:fillRef idx="3">
-            <a:schemeClr val="accent1"/>
-          </a:fillRef>
-          <a:effectRef idx="2">
-            <a:schemeClr val="accent1"/>
-          </a:effectRef>
-          <a:fontRef idx="minor">
-            <a:schemeClr val="lt1"/>
-          </a:fontRef>
-        </p:style>
-        <p:txBody>
-          <a:bodyPr rtlCol="0" anchor="ctr" wrap="square" lIns="228600" rIns="228600" tIns="228600"/>
-          <a:lstStyle/>
-          <a:p>
-            <a:pPr algn="ctr">
-              <a:spcAft>
-                <a:spcPts val="800"/>
-              </a:spcAft>
-              <a:defRPr sz="1600" b="1">
-                <a:solidFill>
-                  <a:srgbClr val="21D8A0"/>
-                </a:solidFill>
-              </a:defRPr>
-            </a:pPr>
-            <a:r>
-              <a:t>💎 Microtransactions</a:t>
-            </a:r>
-          </a:p>
-          <a:p>
-            <a:pPr>
-              <a:defRPr sz="1300">
-                <a:solidFill>
-                  <a:srgbClr val="A3B8B0"/>
-                </a:solidFill>
-              </a:defRPr>
-            </a:pPr>
-            <a:r>
-              <a:t>Guild creation tokens, premium avatar customization items, nickname change passes ($0.99–$9.99).</a:t>
-            </a:r>
-          </a:p>
-        </p:txBody>
-      </p:sp>
-      <p:sp>
-        <p:nvSpPr>
-          <p:cNvPr id="6" name="Rounded Rectangle 5"/>
-          <p:cNvSpPr/>
-          <p:nvPr/>
-        </p:nvSpPr>
-        <p:spPr>
-          <a:xfrm>
-            <a:off x="6309359" y="4023360"/>
-            <a:ext cx="5120640" cy="2103120"/>
-          </a:xfrm>
-          <a:prstGeom prst="roundRect">
-            <a:avLst/>
-          </a:prstGeom>
-          <a:solidFill>
-            <a:srgbClr val="12241E"/>
-          </a:solidFill>
-          <a:ln w="19050">
-            <a:solidFill>
-              <a:srgbClr val="21D8A0"/>
-            </a:solidFill>
-          </a:ln>
-        </p:spPr>
-        <p:style>
-          <a:lnRef idx="1">
-            <a:schemeClr val="accent1"/>
-          </a:lnRef>
-          <a:fillRef idx="3">
-            <a:schemeClr val="accent1"/>
-          </a:fillRef>
-          <a:effectRef idx="2">
-            <a:schemeClr val="accent1"/>
-          </a:effectRef>
-          <a:fontRef idx="minor">
-            <a:schemeClr val="lt1"/>
-          </a:fontRef>
-        </p:style>
-        <p:txBody>
-          <a:bodyPr rtlCol="0" anchor="ctr" wrap="square" lIns="228600" rIns="228600" tIns="228600"/>
-          <a:lstStyle/>
-          <a:p>
-            <a:pPr algn="ctr">
-              <a:spcAft>
-                <a:spcPts val="800"/>
-              </a:spcAft>
-              <a:defRPr sz="1600" b="1">
-                <a:solidFill>
-                  <a:srgbClr val="21D8A0"/>
-                </a:solidFill>
-              </a:defRPr>
-            </a:pPr>
-            <a:r>
-              <a:t>📊 B2B Fitness Analytics</a:t>
-            </a:r>
-          </a:p>
-          <a:p>
-            <a:pPr>
-              <a:defRPr sz="1300">
-                <a:solidFill>
-                  <a:srgbClr val="A3B8B0"/>
-                </a:solidFill>
-              </a:defRPr>
-            </a:pPr>
-            <a:r>
-              <a:t>Anonymized urban mobility insights for municipal planning &amp; fitness brand partnerships.</a:t>
+              <a:t>Qalqon, Qilichlar, Toj, Yashin, Olov kabi eksklyuziv gerblar bilan jamoa statusini ko'rsating.</a:t>
             </a:r>
           </a:p>
         </p:txBody>
@@ -4430,7 +4593,7 @@
               </a:defRPr>
             </a:pPr>
             <a:r>
-              <a:t>DON'T STOP — PITCH DECK</a:t>
+              <a:t>DON'T STOP — INVESTOR PITCH DECK</a:t>
             </a:r>
           </a:p>
           <a:p>
@@ -4442,7 +4605,7 @@
               </a:defRPr>
             </a:pPr>
             <a:r>
-              <a:t>Growth Forecast &amp; 3-Year Milestones</a:t>
+              <a:t>Foydalanuvchini Ushlab Qolish va Maxfiylik</a:t>
             </a:r>
           </a:p>
         </p:txBody>
@@ -4456,7 +4619,7 @@
         <p:spPr>
           <a:xfrm>
             <a:off x="731520" y="1645920"/>
-            <a:ext cx="2011680" cy="4663440"/>
+            <a:ext cx="3291840" cy="4389120"/>
           </a:xfrm>
           <a:prstGeom prst="roundRect">
             <a:avLst/>
@@ -4485,12 +4648,38 @@
           </a:fontRef>
         </p:style>
         <p:txBody>
-          <a:bodyPr rtlCol="0" anchor="ctr" wrap="square" lIns="137160" rIns="137160" tIns="137160"/>
-          <a:lstStyle/>
-          <a:p>
-            <a:pPr algn="ctr">
+          <a:bodyPr rtlCol="0" anchor="ctr"/>
+          <a:lstStyle/>
+          <a:p>
+            <a:pPr algn="ctr"/>
+          </a:p>
+        </p:txBody>
+      </p:sp>
+      <p:sp>
+        <p:nvSpPr>
+          <p:cNvPr id="4" name="TextBox 3"/>
+          <p:cNvSpPr txBox="1"/>
+          <p:nvPr/>
+        </p:nvSpPr>
+        <p:spPr>
+          <a:xfrm>
+            <a:off x="868680" y="1783080"/>
+            <a:ext cx="3017520" cy="4114800"/>
+          </a:xfrm>
+          <a:prstGeom prst="rect">
+            <a:avLst/>
+          </a:prstGeom>
+          <a:noFill/>
+        </p:spPr>
+        <p:txBody>
+          <a:bodyPr wrap="square">
+            <a:spAutoFit/>
+          </a:bodyPr>
+          <a:lstStyle/>
+          <a:p>
+            <a:pPr>
               <a:spcAft>
-                <a:spcPts val="200"/>
+                <a:spcPts val="600"/>
               </a:spcAft>
               <a:defRPr sz="1600" b="1">
                 <a:solidFill>
@@ -4499,78 +4688,33 @@
               </a:defRPr>
             </a:pPr>
             <a:r>
-              <a:t>3 Months</a:t>
-            </a:r>
-          </a:p>
-          <a:p>
-            <a:pPr>
-              <a:spcAft>
-                <a:spcPts val="1000"/>
-              </a:spcAft>
-              <a:defRPr sz="1100" b="1">
-                <a:solidFill>
-                  <a:srgbClr val="FFFFFF"/>
-                </a:solidFill>
-              </a:defRPr>
-            </a:pPr>
-            <a:r>
-              <a:t>Pilot Launch</a:t>
-            </a:r>
-          </a:p>
-          <a:p>
-            <a:pPr>
-              <a:spcAft>
-                <a:spcPts val="400"/>
-              </a:spcAft>
-              <a:defRPr sz="1300" b="1">
-                <a:solidFill>
-                  <a:srgbClr val="00E5FF"/>
-                </a:solidFill>
-              </a:defRPr>
-            </a:pPr>
-            <a:r>
-              <a:t>👥 15K Users</a:t>
-            </a:r>
-          </a:p>
-          <a:p>
-            <a:pPr>
-              <a:spcAft>
-                <a:spcPts val="1200"/>
-              </a:spcAft>
-              <a:defRPr sz="1200" b="1">
-                <a:solidFill>
-                  <a:srgbClr val="FFB800"/>
-                </a:solidFill>
-              </a:defRPr>
-            </a:pPr>
-            <a:r>
-              <a:t>🛡️ 500 Guilds</a:t>
-            </a:r>
-          </a:p>
-          <a:p>
-            <a:pPr>
-              <a:defRPr sz="1100">
+              <a:t>HAFTALIK SIKL</a:t>
+            </a:r>
+          </a:p>
+          <a:p>
+            <a:pPr>
+              <a:defRPr sz="1300">
                 <a:solidFill>
                   <a:srgbClr val="A3B8B0"/>
                 </a:solidFill>
               </a:defRPr>
             </a:pPr>
             <a:r>
-              <a:t>Nukus &amp; Tashkent rollout, APK release.</a:t>
-            </a:r>
-          </a:p>
-        </p:txBody>
-      </p:sp>
-      <p:sp>
-        <p:nvSpPr>
-          <p:cNvPr id="4" name="Rounded Rectangle 3"/>
+              <a:t>Hudud uchun haftalik bellashuv va sovrinlar yangi maqsad yaratadi.</a:t>
+            </a:r>
+          </a:p>
+        </p:txBody>
+      </p:sp>
+      <p:sp>
+        <p:nvSpPr>
+          <p:cNvPr id="5" name="Rounded Rectangle 4"/>
           <p:cNvSpPr/>
           <p:nvPr/>
         </p:nvSpPr>
         <p:spPr>
           <a:xfrm>
-            <a:off x="1989983848319" y="1645920"/>
-            <a:ext cx="2011680" cy="4663440"/>
+            <a:off x="4389120" y="1645920"/>
+            <a:ext cx="3291840" cy="4389120"/>
           </a:xfrm>
           <a:prstGeom prst="roundRect">
             <a:avLst/>
@@ -4580,7 +4724,7 @@
           </a:solidFill>
           <a:ln w="19050">
             <a:solidFill>
-              <a:srgbClr val="21D8A0"/>
+              <a:srgbClr val="00E5FF"/>
             </a:solidFill>
           </a:ln>
         </p:spPr>
@@ -4599,92 +4743,73 @@
           </a:fontRef>
         </p:style>
         <p:txBody>
-          <a:bodyPr rtlCol="0" anchor="ctr" wrap="square" lIns="137160" rIns="137160" tIns="137160"/>
-          <a:lstStyle/>
-          <a:p>
-            <a:pPr algn="ctr">
+          <a:bodyPr rtlCol="0" anchor="ctr"/>
+          <a:lstStyle/>
+          <a:p>
+            <a:pPr algn="ctr"/>
+          </a:p>
+        </p:txBody>
+      </p:sp>
+      <p:sp>
+        <p:nvSpPr>
+          <p:cNvPr id="6" name="TextBox 5"/>
+          <p:cNvSpPr txBox="1"/>
+          <p:nvPr/>
+        </p:nvSpPr>
+        <p:spPr>
+          <a:xfrm>
+            <a:off x="4526280" y="1783080"/>
+            <a:ext cx="3017520" cy="4114800"/>
+          </a:xfrm>
+          <a:prstGeom prst="rect">
+            <a:avLst/>
+          </a:prstGeom>
+          <a:noFill/>
+        </p:spPr>
+        <p:txBody>
+          <a:bodyPr wrap="square">
+            <a:spAutoFit/>
+          </a:bodyPr>
+          <a:lstStyle/>
+          <a:p>
+            <a:pPr>
               <a:spcAft>
-                <a:spcPts val="200"/>
+                <a:spcPts val="600"/>
               </a:spcAft>
               <a:defRPr sz="1600" b="1">
                 <a:solidFill>
-                  <a:srgbClr val="21D8A0"/>
-                </a:solidFill>
-              </a:defRPr>
-            </a:pPr>
-            <a:r>
-              <a:t>6 Months</a:t>
-            </a:r>
-          </a:p>
-          <a:p>
-            <a:pPr>
-              <a:spcAft>
-                <a:spcPts val="1000"/>
-              </a:spcAft>
-              <a:defRPr sz="1100" b="1">
-                <a:solidFill>
-                  <a:srgbClr val="FFFFFF"/>
-                </a:solidFill>
-              </a:defRPr>
-            </a:pPr>
-            <a:r>
-              <a:t>Regional Push</a:t>
-            </a:r>
-          </a:p>
-          <a:p>
-            <a:pPr>
-              <a:spcAft>
-                <a:spcPts val="400"/>
-              </a:spcAft>
-              <a:defRPr sz="1300" b="1">
-                <a:solidFill>
                   <a:srgbClr val="00E5FF"/>
                 </a:solidFill>
               </a:defRPr>
             </a:pPr>
             <a:r>
-              <a:t>👥 75K Users</a:t>
-            </a:r>
-          </a:p>
-          <a:p>
-            <a:pPr>
-              <a:spcAft>
-                <a:spcPts val="1200"/>
-              </a:spcAft>
-              <a:defRPr sz="1200" b="1">
-                <a:solidFill>
-                  <a:srgbClr val="FFB800"/>
-                </a:solidFill>
-              </a:defRPr>
-            </a:pPr>
-            <a:r>
-              <a:t>🛡️ 2.5K Guilds</a:t>
-            </a:r>
-          </a:p>
-          <a:p>
-            <a:pPr>
-              <a:defRPr sz="1100">
+              <a:t>MAXFIYLIK ZONASI</a:t>
+            </a:r>
+          </a:p>
+          <a:p>
+            <a:pPr>
+              <a:defRPr sz="1300">
                 <a:solidFill>
                   <a:srgbClr val="A3B8B0"/>
                 </a:solidFill>
               </a:defRPr>
             </a:pPr>
             <a:r>
-              <a:t>Samarkand, Almaty, Shymkent ($12K/mo rev).</a:t>
-            </a:r>
-          </a:p>
-        </p:txBody>
-      </p:sp>
-      <p:sp>
-        <p:nvSpPr>
-          <p:cNvPr id="5" name="Rounded Rectangle 4"/>
+              <a:t>200 metrli Privacy Radius uyingiz va shaxsiy manzillaringizni yashiradi.</a:t>
+            </a:r>
+          </a:p>
+        </p:txBody>
+      </p:sp>
+      <p:sp>
+        <p:nvSpPr>
+          <p:cNvPr id="7" name="Rounded Rectangle 6"/>
           <p:cNvSpPr/>
           <p:nvPr/>
         </p:nvSpPr>
         <p:spPr>
           <a:xfrm>
-            <a:off x="3979966965120" y="1645920"/>
-            <a:ext cx="2011680" cy="4663440"/>
+            <a:off x="8046720" y="1645920"/>
+            <a:ext cx="3291840" cy="4389120"/>
           </a:xfrm>
           <a:prstGeom prst="roundRect">
             <a:avLst/>
@@ -4713,12 +4838,38 @@
           </a:fontRef>
         </p:style>
         <p:txBody>
-          <a:bodyPr rtlCol="0" anchor="ctr" wrap="square" lIns="137160" rIns="137160" tIns="137160"/>
-          <a:lstStyle/>
-          <a:p>
-            <a:pPr algn="ctr">
+          <a:bodyPr rtlCol="0" anchor="ctr"/>
+          <a:lstStyle/>
+          <a:p>
+            <a:pPr algn="ctr"/>
+          </a:p>
+        </p:txBody>
+      </p:sp>
+      <p:sp>
+        <p:nvSpPr>
+          <p:cNvPr id="8" name="TextBox 7"/>
+          <p:cNvSpPr txBox="1"/>
+          <p:nvPr/>
+        </p:nvSpPr>
+        <p:spPr>
+          <a:xfrm>
+            <a:off x="8183880" y="1783080"/>
+            <a:ext cx="3017520" cy="4114800"/>
+          </a:xfrm>
+          <a:prstGeom prst="rect">
+            <a:avLst/>
+          </a:prstGeom>
+          <a:noFill/>
+        </p:spPr>
+        <p:txBody>
+          <a:bodyPr wrap="square">
+            <a:spAutoFit/>
+          </a:bodyPr>
+          <a:lstStyle/>
+          <a:p>
+            <a:pPr>
               <a:spcAft>
-                <a:spcPts val="200"/>
+                <a:spcPts val="600"/>
               </a:spcAft>
               <a:defRPr sz="1600" b="1">
                 <a:solidFill>
@@ -4727,292 +4878,19 @@
               </a:defRPr>
             </a:pPr>
             <a:r>
-              <a:t>1 Year</a:t>
-            </a:r>
-          </a:p>
-          <a:p>
-            <a:pPr>
-              <a:spcAft>
-                <a:spcPts val="1000"/>
-              </a:spcAft>
-              <a:defRPr sz="1100" b="1">
-                <a:solidFill>
-                  <a:srgbClr val="FFFFFF"/>
-                </a:solidFill>
-              </a:defRPr>
-            </a:pPr>
-            <a:r>
-              <a:t>Multi-Country</a:t>
-            </a:r>
-          </a:p>
-          <a:p>
-            <a:pPr>
-              <a:spcAft>
-                <a:spcPts val="400"/>
-              </a:spcAft>
-              <a:defRPr sz="1300" b="1">
-                <a:solidFill>
-                  <a:srgbClr val="00E5FF"/>
-                </a:solidFill>
-              </a:defRPr>
-            </a:pPr>
-            <a:r>
-              <a:t>👥 300K Users</a:t>
-            </a:r>
-          </a:p>
-          <a:p>
-            <a:pPr>
-              <a:spcAft>
-                <a:spcPts val="1200"/>
-              </a:spcAft>
-              <a:defRPr sz="1200" b="1">
-                <a:solidFill>
-                  <a:srgbClr val="FFB800"/>
-                </a:solidFill>
-              </a:defRPr>
-            </a:pPr>
-            <a:r>
-              <a:t>🛡️ 10K Guilds</a:t>
-            </a:r>
-          </a:p>
-          <a:p>
-            <a:pPr>
-              <a:defRPr sz="1100">
+              <a:t>ANTI-CHEAT</a:t>
+            </a:r>
+          </a:p>
+          <a:p>
+            <a:pPr>
+              <a:defRPr sz="1300">
                 <a:solidFill>
                   <a:srgbClr val="A3B8B0"/>
                 </a:solidFill>
               </a:defRPr>
             </a:pPr>
             <a:r>
-              <a:t>Istanbul, Astana, Baku ($50K/mo rev).</a:t>
-            </a:r>
-          </a:p>
-        </p:txBody>
-      </p:sp>
-      <p:sp>
-        <p:nvSpPr>
-          <p:cNvPr id="6" name="Rounded Rectangle 5"/>
-          <p:cNvSpPr/>
-          <p:nvPr/>
-        </p:nvSpPr>
-        <p:spPr>
-          <a:xfrm>
-            <a:off x="5969950081920" y="1645920"/>
-            <a:ext cx="2011680" cy="4663440"/>
-          </a:xfrm>
-          <a:prstGeom prst="roundRect">
-            <a:avLst/>
-          </a:prstGeom>
-          <a:solidFill>
-            <a:srgbClr val="12241E"/>
-          </a:solidFill>
-          <a:ln w="19050">
-            <a:solidFill>
-              <a:srgbClr val="00E5FF"/>
-            </a:solidFill>
-          </a:ln>
-        </p:spPr>
-        <p:style>
-          <a:lnRef idx="1">
-            <a:schemeClr val="accent1"/>
-          </a:lnRef>
-          <a:fillRef idx="3">
-            <a:schemeClr val="accent1"/>
-          </a:fillRef>
-          <a:effectRef idx="2">
-            <a:schemeClr val="accent1"/>
-          </a:effectRef>
-          <a:fontRef idx="minor">
-            <a:schemeClr val="lt1"/>
-          </a:fontRef>
-        </p:style>
-        <p:txBody>
-          <a:bodyPr rtlCol="0" anchor="ctr" wrap="square" lIns="137160" rIns="137160" tIns="137160"/>
-          <a:lstStyle/>
-          <a:p>
-            <a:pPr algn="ctr">
-              <a:spcAft>
-                <a:spcPts val="200"/>
-              </a:spcAft>
-              <a:defRPr sz="1600" b="1">
-                <a:solidFill>
-                  <a:srgbClr val="21D8A0"/>
-                </a:solidFill>
-              </a:defRPr>
-            </a:pPr>
-            <a:r>
-              <a:t>2 Years</a:t>
-            </a:r>
-          </a:p>
-          <a:p>
-            <a:pPr>
-              <a:spcAft>
-                <a:spcPts val="1000"/>
-              </a:spcAft>
-              <a:defRPr sz="1100" b="1">
-                <a:solidFill>
-                  <a:srgbClr val="FFFFFF"/>
-                </a:solidFill>
-              </a:defRPr>
-            </a:pPr>
-            <a:r>
-              <a:t>Global Expansion</a:t>
-            </a:r>
-          </a:p>
-          <a:p>
-            <a:pPr>
-              <a:spcAft>
-                <a:spcPts val="400"/>
-              </a:spcAft>
-              <a:defRPr sz="1300" b="1">
-                <a:solidFill>
-                  <a:srgbClr val="00E5FF"/>
-                </a:solidFill>
-              </a:defRPr>
-            </a:pPr>
-            <a:r>
-              <a:t>👥 1.2M Users</a:t>
-            </a:r>
-          </a:p>
-          <a:p>
-            <a:pPr>
-              <a:spcAft>
-                <a:spcPts val="1200"/>
-              </a:spcAft>
-              <a:defRPr sz="1200" b="1">
-                <a:solidFill>
-                  <a:srgbClr val="FFB800"/>
-                </a:solidFill>
-              </a:defRPr>
-            </a:pPr>
-            <a:r>
-              <a:t>🛡️ 40K Guilds</a:t>
-            </a:r>
-          </a:p>
-          <a:p>
-            <a:pPr>
-              <a:defRPr sz="1100">
-                <a:solidFill>
-                  <a:srgbClr val="A3B8B0"/>
-                </a:solidFill>
-              </a:defRPr>
-            </a:pPr>
-            <a:r>
-              <a:t>MENA &amp; Eastern Europe ($180K/mo rev).</a:t>
-            </a:r>
-          </a:p>
-        </p:txBody>
-      </p:sp>
-      <p:sp>
-        <p:nvSpPr>
-          <p:cNvPr id="7" name="Rounded Rectangle 6"/>
-          <p:cNvSpPr/>
-          <p:nvPr/>
-        </p:nvSpPr>
-        <p:spPr>
-          <a:xfrm>
-            <a:off x="7959933198720" y="1645920"/>
-            <a:ext cx="2011680" cy="4663440"/>
-          </a:xfrm>
-          <a:prstGeom prst="roundRect">
-            <a:avLst/>
-          </a:prstGeom>
-          <a:solidFill>
-            <a:srgbClr val="12241E"/>
-          </a:solidFill>
-          <a:ln w="19050">
-            <a:solidFill>
-              <a:srgbClr val="00E5FF"/>
-            </a:solidFill>
-          </a:ln>
-        </p:spPr>
-        <p:style>
-          <a:lnRef idx="1">
-            <a:schemeClr val="accent1"/>
-          </a:lnRef>
-          <a:fillRef idx="3">
-            <a:schemeClr val="accent1"/>
-          </a:fillRef>
-          <a:effectRef idx="2">
-            <a:schemeClr val="accent1"/>
-          </a:effectRef>
-          <a:fontRef idx="minor">
-            <a:schemeClr val="lt1"/>
-          </a:fontRef>
-        </p:style>
-        <p:txBody>
-          <a:bodyPr rtlCol="0" anchor="ctr" wrap="square" lIns="137160" rIns="137160" tIns="137160"/>
-          <a:lstStyle/>
-          <a:p>
-            <a:pPr algn="ctr">
-              <a:spcAft>
-                <a:spcPts val="200"/>
-              </a:spcAft>
-              <a:defRPr sz="1600" b="1">
-                <a:solidFill>
-                  <a:srgbClr val="21D8A0"/>
-                </a:solidFill>
-              </a:defRPr>
-            </a:pPr>
-            <a:r>
-              <a:t>3 Years</a:t>
-            </a:r>
-          </a:p>
-          <a:p>
-            <a:pPr>
-              <a:spcAft>
-                <a:spcPts val="1000"/>
-              </a:spcAft>
-              <a:defRPr sz="1100" b="1">
-                <a:solidFill>
-                  <a:srgbClr val="FFFFFF"/>
-                </a:solidFill>
-              </a:defRPr>
-            </a:pPr>
-            <a:r>
-              <a:t>Ecosystem Scale</a:t>
-            </a:r>
-          </a:p>
-          <a:p>
-            <a:pPr>
-              <a:spcAft>
-                <a:spcPts val="400"/>
-              </a:spcAft>
-              <a:defRPr sz="1300" b="1">
-                <a:solidFill>
-                  <a:srgbClr val="00E5FF"/>
-                </a:solidFill>
-              </a:defRPr>
-            </a:pPr>
-            <a:r>
-              <a:t>👥 4.5M Users</a:t>
-            </a:r>
-          </a:p>
-          <a:p>
-            <a:pPr>
-              <a:spcAft>
-                <a:spcPts val="1200"/>
-              </a:spcAft>
-              <a:defRPr sz="1200" b="1">
-                <a:solidFill>
-                  <a:srgbClr val="FFB800"/>
-                </a:solidFill>
-              </a:defRPr>
-            </a:pPr>
-            <a:r>
-              <a:t>🛡️ 150K Guilds</a:t>
-            </a:r>
-          </a:p>
-          <a:p>
-            <a:pPr>
-              <a:defRPr sz="1100">
-                <a:solidFill>
-                  <a:srgbClr val="A3B8B0"/>
-                </a:solidFill>
-              </a:defRPr>
-            </a:pPr>
-            <a:r>
-              <a:t>Global B2B Sponsors ($4M+ Annual Rev).</a:t>
+              <a:t>Teleportatsiyani aniqlash va GPS sifat filtri soxta treklarni bloklaydi.</a:t>
             </a:r>
           </a:p>
         </p:txBody>
@@ -5076,7 +4954,7 @@
               </a:defRPr>
             </a:pPr>
             <a:r>
-              <a:t>DON'T STOP — PITCH DECK</a:t>
+              <a:t>DON'T STOP — INVESTOR PITCH DECK</a:t>
             </a:r>
           </a:p>
           <a:p>
@@ -5088,7 +4966,7 @@
               </a:defRPr>
             </a:pPr>
             <a:r>
-              <a:t>Funding Request: Minimum $50,000 USD (12-Month Runway)</a:t>
+              <a:t>Raqobatchilar va Don't Stop Ustunligi</a:t>
             </a:r>
           </a:p>
         </p:txBody>
@@ -5102,7 +4980,7 @@
         <p:spPr>
           <a:xfrm>
             <a:off x="731520" y="1645920"/>
-            <a:ext cx="3840480" cy="4663440"/>
+            <a:ext cx="3291840" cy="4389120"/>
           </a:xfrm>
           <a:prstGeom prst="roundRect">
             <a:avLst/>
@@ -5110,9 +4988,9 @@
           <a:solidFill>
             <a:srgbClr val="12241E"/>
           </a:solidFill>
-          <a:ln w="25400">
+          <a:ln w="19050">
             <a:solidFill>
-              <a:srgbClr val="FFB800"/>
+              <a:srgbClr val="21D8A0"/>
             </a:solidFill>
           </a:ln>
         </p:spPr>
@@ -5131,125 +5009,73 @@
           </a:fontRef>
         </p:style>
         <p:txBody>
-          <a:bodyPr rtlCol="0" anchor="ctr" wrap="square" lIns="274320" rIns="274320" tIns="274320"/>
-          <a:lstStyle/>
-          <a:p>
-            <a:pPr algn="ctr">
+          <a:bodyPr rtlCol="0" anchor="ctr"/>
+          <a:lstStyle/>
+          <a:p>
+            <a:pPr algn="ctr"/>
+          </a:p>
+        </p:txBody>
+      </p:sp>
+      <p:sp>
+        <p:nvSpPr>
+          <p:cNvPr id="4" name="TextBox 3"/>
+          <p:cNvSpPr txBox="1"/>
+          <p:nvPr/>
+        </p:nvSpPr>
+        <p:spPr>
+          <a:xfrm>
+            <a:off x="868680" y="1783080"/>
+            <a:ext cx="3017520" cy="4114800"/>
+          </a:xfrm>
+          <a:prstGeom prst="rect">
+            <a:avLst/>
+          </a:prstGeom>
+          <a:noFill/>
+        </p:spPr>
+        <p:txBody>
+          <a:bodyPr wrap="square">
+            <a:spAutoFit/>
+          </a:bodyPr>
+          <a:lstStyle/>
+          <a:p>
+            <a:pPr>
               <a:spcAft>
-                <a:spcPts val="1000"/>
+                <a:spcPts val="600"/>
               </a:spcAft>
-              <a:defRPr sz="1800" b="1">
-                <a:solidFill>
-                  <a:srgbClr val="FFB800"/>
-                </a:solidFill>
-              </a:defRPr>
-            </a:pPr>
-            <a:r>
-              <a:t>💰 INVESTMENT ASK</a:t>
-            </a:r>
-          </a:p>
-          <a:p>
-            <a:pPr>
-              <a:spcAft>
-                <a:spcPts val="1600"/>
-              </a:spcAft>
-              <a:defRPr sz="3200" b="1">
+              <a:defRPr sz="1600" b="1">
                 <a:solidFill>
                   <a:srgbClr val="21D8A0"/>
                 </a:solidFill>
               </a:defRPr>
             </a:pPr>
             <a:r>
-              <a:t>$50,000 USD</a:t>
-            </a:r>
-          </a:p>
-          <a:p>
-            <a:pPr>
-              <a:spcAft>
-                <a:spcPts val="800"/>
-              </a:spcAft>
-              <a:defRPr sz="1200">
-                <a:solidFill>
-                  <a:srgbClr val="FFFFFF"/>
-                </a:solidFill>
-              </a:defRPr>
-            </a:pPr>
-            <a:r>
-              <a:t>✔  12-Month Operational Runway</a:t>
-            </a:r>
-          </a:p>
-          <a:p>
-            <a:pPr>
-              <a:spcAft>
-                <a:spcPts val="800"/>
-              </a:spcAft>
-              <a:defRPr sz="1200">
-                <a:solidFill>
-                  <a:srgbClr val="FFFFFF"/>
-                </a:solidFill>
-              </a:defRPr>
-            </a:pPr>
-            <a:r>
-              <a:t>✔  Full Mobile APK Launch &amp; Growth</a:t>
-            </a:r>
-          </a:p>
-          <a:p>
-            <a:pPr>
-              <a:spcAft>
-                <a:spcPts val="800"/>
-              </a:spcAft>
-              <a:defRPr sz="1200">
-                <a:solidFill>
-                  <a:srgbClr val="FFFFFF"/>
-                </a:solidFill>
-              </a:defRPr>
-            </a:pPr>
-            <a:r>
-              <a:t>✔  Team Salary Coverage (5 Key Roles)</a:t>
-            </a:r>
-          </a:p>
-          <a:p>
-            <a:pPr>
-              <a:spcAft>
-                <a:spcPts val="800"/>
-              </a:spcAft>
-              <a:defRPr sz="1200">
-                <a:solidFill>
-                  <a:srgbClr val="FFFFFF"/>
-                </a:solidFill>
-              </a:defRPr>
-            </a:pPr>
-            <a:r>
-              <a:t>✔  Server &amp; Map Infrastructure Scale</a:t>
-            </a:r>
-          </a:p>
-          <a:p>
-            <a:pPr>
-              <a:spcAft>
-                <a:spcPts val="800"/>
-              </a:spcAft>
-              <a:defRPr sz="1200">
-                <a:solidFill>
-                  <a:srgbClr val="FFFFFF"/>
-                </a:solidFill>
-              </a:defRPr>
-            </a:pPr>
-            <a:r>
-              <a:t>✔  Local Influencer &amp; Campus Marketing</a:t>
-            </a:r>
-          </a:p>
-        </p:txBody>
-      </p:sp>
-      <p:sp>
-        <p:nvSpPr>
-          <p:cNvPr id="4" name="Rounded Rectangle 3"/>
+              <a:t>Don't Stop</a:t>
+            </a:r>
+          </a:p>
+          <a:p>
+            <a:pPr>
+              <a:defRPr sz="1300">
+                <a:solidFill>
+                  <a:srgbClr val="A3B8B0"/>
+                </a:solidFill>
+              </a:defRPr>
+            </a:pPr>
+            <a:r>
+              <a:t>Real-time Closed-loop GPS + 10-player Guild Warfare + 200m Privacy Radius + Multi-language.</a:t>
+            </a:r>
+          </a:p>
+        </p:txBody>
+      </p:sp>
+      <p:sp>
+        <p:nvSpPr>
+          <p:cNvPr id="5" name="Rounded Rectangle 4"/>
           <p:cNvSpPr/>
           <p:nvPr/>
         </p:nvSpPr>
         <p:spPr>
           <a:xfrm>
-            <a:off x="4846320" y="1645920"/>
-            <a:ext cx="6583680" cy="685800"/>
+            <a:off x="4389120" y="1645920"/>
+            <a:ext cx="3291840" cy="4389120"/>
           </a:xfrm>
           <a:prstGeom prst="roundRect">
             <a:avLst/>
@@ -5257,7 +5083,7 @@
           <a:solidFill>
             <a:srgbClr val="12241E"/>
           </a:solidFill>
-          <a:ln w="12700">
+          <a:ln w="19050">
             <a:solidFill>
               <a:srgbClr val="21D8A0"/>
             </a:solidFill>
@@ -5278,52 +5104,73 @@
           </a:fontRef>
         </p:style>
         <p:txBody>
-          <a:bodyPr rtlCol="0" anchor="ctr" wrap="square" lIns="182880" tIns="91440"/>
-          <a:lstStyle/>
-          <a:p>
-            <a:pPr algn="ctr">
-              <a:defRPr sz="1300" b="1">
-                <a:solidFill>
-                  <a:srgbClr val="FFFFFF"/>
-                </a:solidFill>
-              </a:defRPr>
-            </a:pPr>
-            <a:r>
-              <a:t>Backend Developer  —  </a:t>
-            </a:r>
-            <a:r>
-              <a:rPr b="1">
-                <a:solidFill>
-                  <a:srgbClr val="FFB800"/>
-                </a:solidFill>
-              </a:rPr>
-              <a:t>$12,000 (24%)</a:t>
-            </a:r>
-          </a:p>
-          <a:p>
-            <a:pPr>
-              <a:defRPr sz="1050">
+          <a:bodyPr rtlCol="0" anchor="ctr"/>
+          <a:lstStyle/>
+          <a:p>
+            <a:pPr algn="ctr"/>
+          </a:p>
+        </p:txBody>
+      </p:sp>
+      <p:sp>
+        <p:nvSpPr>
+          <p:cNvPr id="6" name="TextBox 5"/>
+          <p:cNvSpPr txBox="1"/>
+          <p:nvPr/>
+        </p:nvSpPr>
+        <p:spPr>
+          <a:xfrm>
+            <a:off x="4526280" y="1783080"/>
+            <a:ext cx="3017520" cy="4114800"/>
+          </a:xfrm>
+          <a:prstGeom prst="rect">
+            <a:avLst/>
+          </a:prstGeom>
+          <a:noFill/>
+        </p:spPr>
+        <p:txBody>
+          <a:bodyPr wrap="square">
+            <a:spAutoFit/>
+          </a:bodyPr>
+          <a:lstStyle/>
+          <a:p>
+            <a:pPr>
+              <a:spcAft>
+                <a:spcPts val="600"/>
+              </a:spcAft>
+              <a:defRPr sz="1600" b="1">
                 <a:solidFill>
                   <a:srgbClr val="A3B8B0"/>
                 </a:solidFill>
               </a:defRPr>
             </a:pPr>
             <a:r>
-              <a:t>Spatial PostGIS API, Anti-cheat algorithms, Real-time WebSockets</a:t>
-            </a:r>
-          </a:p>
-        </p:txBody>
-      </p:sp>
-      <p:sp>
-        <p:nvSpPr>
-          <p:cNvPr id="5" name="Rounded Rectangle 4"/>
+              <a:t>Strava / Nike Run</a:t>
+            </a:r>
+          </a:p>
+          <a:p>
+            <a:pPr>
+              <a:defRPr sz="1300">
+                <a:solidFill>
+                  <a:srgbClr val="A3B8B0"/>
+                </a:solidFill>
+              </a:defRPr>
+            </a:pPr>
+            <a:r>
+              <a:t>Faqat statistikani kuzatish. Jamoaviy hudud egallash va o'yin mexanikasi 0%.</a:t>
+            </a:r>
+          </a:p>
+        </p:txBody>
+      </p:sp>
+      <p:sp>
+        <p:nvSpPr>
+          <p:cNvPr id="7" name="Rounded Rectangle 6"/>
           <p:cNvSpPr/>
           <p:nvPr/>
         </p:nvSpPr>
         <p:spPr>
           <a:xfrm>
-            <a:off x="4846320" y="2404872"/>
-            <a:ext cx="6583680" cy="685800"/>
+            <a:off x="8046720" y="1645920"/>
+            <a:ext cx="3291840" cy="4389120"/>
           </a:xfrm>
           <a:prstGeom prst="roundRect">
             <a:avLst/>
@@ -5331,7 +5178,7 @@
           <a:solidFill>
             <a:srgbClr val="12241E"/>
           </a:solidFill>
-          <a:ln w="12700">
+          <a:ln w="19050">
             <a:solidFill>
               <a:srgbClr val="21D8A0"/>
             </a:solidFill>
@@ -5352,334 +5199,59 @@
           </a:fontRef>
         </p:style>
         <p:txBody>
-          <a:bodyPr rtlCol="0" anchor="ctr" wrap="square" lIns="182880" tIns="91440"/>
-          <a:lstStyle/>
-          <a:p>
-            <a:pPr algn="ctr">
-              <a:defRPr sz="1300" b="1">
-                <a:solidFill>
-                  <a:srgbClr val="FFFFFF"/>
-                </a:solidFill>
-              </a:defRPr>
-            </a:pPr>
-            <a:r>
-              <a:t>Frontend &amp; UI/UX Developer  —  </a:t>
-            </a:r>
-            <a:r>
-              <a:rPr b="1">
-                <a:solidFill>
-                  <a:srgbClr val="FFB800"/>
-                </a:solidFill>
-              </a:rPr>
-              <a:t>$10,000 (20%)</a:t>
-            </a:r>
-          </a:p>
-          <a:p>
-            <a:pPr>
-              <a:defRPr sz="1050">
+          <a:bodyPr rtlCol="0" anchor="ctr"/>
+          <a:lstStyle/>
+          <a:p>
+            <a:pPr algn="ctr"/>
+          </a:p>
+        </p:txBody>
+      </p:sp>
+      <p:sp>
+        <p:nvSpPr>
+          <p:cNvPr id="8" name="TextBox 7"/>
+          <p:cNvSpPr txBox="1"/>
+          <p:nvPr/>
+        </p:nvSpPr>
+        <p:spPr>
+          <a:xfrm>
+            <a:off x="8183880" y="1783080"/>
+            <a:ext cx="3017520" cy="4114800"/>
+          </a:xfrm>
+          <a:prstGeom prst="rect">
+            <a:avLst/>
+          </a:prstGeom>
+          <a:noFill/>
+        </p:spPr>
+        <p:txBody>
+          <a:bodyPr wrap="square">
+            <a:spAutoFit/>
+          </a:bodyPr>
+          <a:lstStyle/>
+          <a:p>
+            <a:pPr>
+              <a:spcAft>
+                <a:spcPts val="600"/>
+              </a:spcAft>
+              <a:defRPr sz="1600" b="1">
                 <a:solidFill>
                   <a:srgbClr val="A3B8B0"/>
                 </a:solidFill>
               </a:defRPr>
             </a:pPr>
             <a:r>
-              <a:t>MapLibre GL Vector UI, Capacitor Mobile App, Responsive Dashboards</a:t>
-            </a:r>
-          </a:p>
-        </p:txBody>
-      </p:sp>
-      <p:sp>
-        <p:nvSpPr>
-          <p:cNvPr id="6" name="Rounded Rectangle 5"/>
-          <p:cNvSpPr/>
-          <p:nvPr/>
-        </p:nvSpPr>
-        <p:spPr>
-          <a:xfrm>
-            <a:off x="4846320" y="3163824"/>
-            <a:ext cx="6583680" cy="685800"/>
-          </a:xfrm>
-          <a:prstGeom prst="roundRect">
-            <a:avLst/>
-          </a:prstGeom>
-          <a:solidFill>
-            <a:srgbClr val="12241E"/>
-          </a:solidFill>
-          <a:ln w="12700">
-            <a:solidFill>
-              <a:srgbClr val="21D8A0"/>
-            </a:solidFill>
-          </a:ln>
-        </p:spPr>
-        <p:style>
-          <a:lnRef idx="1">
-            <a:schemeClr val="accent1"/>
-          </a:lnRef>
-          <a:fillRef idx="3">
-            <a:schemeClr val="accent1"/>
-          </a:fillRef>
-          <a:effectRef idx="2">
-            <a:schemeClr val="accent1"/>
-          </a:effectRef>
-          <a:fontRef idx="minor">
-            <a:schemeClr val="lt1"/>
-          </a:fontRef>
-        </p:style>
-        <p:txBody>
-          <a:bodyPr rtlCol="0" anchor="ctr" wrap="square" lIns="182880" tIns="91440"/>
-          <a:lstStyle/>
-          <a:p>
-            <a:pPr algn="ctr">
-              <a:defRPr sz="1300" b="1">
-                <a:solidFill>
-                  <a:srgbClr val="FFFFFF"/>
-                </a:solidFill>
-              </a:defRPr>
-            </a:pPr>
-            <a:r>
-              <a:t>Game Dev / Spatial Engineer  —  </a:t>
-            </a:r>
-            <a:r>
-              <a:rPr b="1">
-                <a:solidFill>
-                  <a:srgbClr val="FFB800"/>
-                </a:solidFill>
-              </a:rPr>
-              <a:t>$10,000 (20%)</a:t>
-            </a:r>
-          </a:p>
-          <a:p>
-            <a:pPr>
-              <a:defRPr sz="1050">
+              <a:t>Pokémon GO / Ingress</a:t>
+            </a:r>
+          </a:p>
+          <a:p>
+            <a:pPr>
+              <a:defRPr sz="1300">
                 <a:solidFill>
                   <a:srgbClr val="A3B8B0"/>
                 </a:solidFill>
               </a:defRPr>
             </a:pPr>
             <a:r>
-              <a:t>Closed-loop vector math, Territory decay engine, Mobile bridge</a:t>
-            </a:r>
-          </a:p>
-        </p:txBody>
-      </p:sp>
-      <p:sp>
-        <p:nvSpPr>
-          <p:cNvPr id="7" name="Rounded Rectangle 6"/>
-          <p:cNvSpPr/>
-          <p:nvPr/>
-        </p:nvSpPr>
-        <p:spPr>
-          <a:xfrm>
-            <a:off x="4846320" y="3922776"/>
-            <a:ext cx="6583680" cy="685800"/>
-          </a:xfrm>
-          <a:prstGeom prst="roundRect">
-            <a:avLst/>
-          </a:prstGeom>
-          <a:solidFill>
-            <a:srgbClr val="12241E"/>
-          </a:solidFill>
-          <a:ln w="12700">
-            <a:solidFill>
-              <a:srgbClr val="21D8A0"/>
-            </a:solidFill>
-          </a:ln>
-        </p:spPr>
-        <p:style>
-          <a:lnRef idx="1">
-            <a:schemeClr val="accent1"/>
-          </a:lnRef>
-          <a:fillRef idx="3">
-            <a:schemeClr val="accent1"/>
-          </a:fillRef>
-          <a:effectRef idx="2">
-            <a:schemeClr val="accent1"/>
-          </a:effectRef>
-          <a:fontRef idx="minor">
-            <a:schemeClr val="lt1"/>
-          </a:fontRef>
-        </p:style>
-        <p:txBody>
-          <a:bodyPr rtlCol="0" anchor="ctr" wrap="square" lIns="182880" tIns="91440"/>
-          <a:lstStyle/>
-          <a:p>
-            <a:pPr algn="ctr">
-              <a:defRPr sz="1300" b="1">
-                <a:solidFill>
-                  <a:srgbClr val="FFFFFF"/>
-                </a:solidFill>
-              </a:defRPr>
-            </a:pPr>
-            <a:r>
-              <a:t>Graphic &amp; Brand Designer  —  </a:t>
-            </a:r>
-            <a:r>
-              <a:rPr b="1">
-                <a:solidFill>
-                  <a:srgbClr val="FFB800"/>
-                </a:solidFill>
-              </a:rPr>
-              <a:t>$6,000 (12%)</a:t>
-            </a:r>
-          </a:p>
-          <a:p>
-            <a:pPr>
-              <a:defRPr sz="1050">
-                <a:solidFill>
-                  <a:srgbClr val="A3B8B0"/>
-                </a:solidFill>
-              </a:defRPr>
-            </a:pPr>
-            <a:r>
-              <a:t>Vector emblem badges, UI assets, Marketing kits &amp; social branding</a:t>
-            </a:r>
-          </a:p>
-        </p:txBody>
-      </p:sp>
-      <p:sp>
-        <p:nvSpPr>
-          <p:cNvPr id="8" name="Rounded Rectangle 7"/>
-          <p:cNvSpPr/>
-          <p:nvPr/>
-        </p:nvSpPr>
-        <p:spPr>
-          <a:xfrm>
-            <a:off x="4846320" y="4681728"/>
-            <a:ext cx="6583680" cy="685800"/>
-          </a:xfrm>
-          <a:prstGeom prst="roundRect">
-            <a:avLst/>
-          </a:prstGeom>
-          <a:solidFill>
-            <a:srgbClr val="12241E"/>
-          </a:solidFill>
-          <a:ln w="12700">
-            <a:solidFill>
-              <a:srgbClr val="21D8A0"/>
-            </a:solidFill>
-          </a:ln>
-        </p:spPr>
-        <p:style>
-          <a:lnRef idx="1">
-            <a:schemeClr val="accent1"/>
-          </a:lnRef>
-          <a:fillRef idx="3">
-            <a:schemeClr val="accent1"/>
-          </a:fillRef>
-          <a:effectRef idx="2">
-            <a:schemeClr val="accent1"/>
-          </a:effectRef>
-          <a:fontRef idx="minor">
-            <a:schemeClr val="lt1"/>
-          </a:fontRef>
-        </p:style>
-        <p:txBody>
-          <a:bodyPr rtlCol="0" anchor="ctr" wrap="square" lIns="182880" tIns="91440"/>
-          <a:lstStyle/>
-          <a:p>
-            <a:pPr algn="ctr">
-              <a:defRPr sz="1300" b="1">
-                <a:solidFill>
-                  <a:srgbClr val="FFFFFF"/>
-                </a:solidFill>
-              </a:defRPr>
-            </a:pPr>
-            <a:r>
-              <a:t>Marketing &amp; Community Mgr  —  </a:t>
-            </a:r>
-            <a:r>
-              <a:rPr b="1">
-                <a:solidFill>
-                  <a:srgbClr val="FFB800"/>
-                </a:solidFill>
-              </a:rPr>
-              <a:t>$7,000 (14%)</a:t>
-            </a:r>
-          </a:p>
-          <a:p>
-            <a:pPr>
-              <a:defRPr sz="1050">
-                <a:solidFill>
-                  <a:srgbClr val="A3B8B0"/>
-                </a:solidFill>
-              </a:defRPr>
-            </a:pPr>
-            <a:r>
-              <a:t>Influencer campaigns, TikTok/Instagram viral runs, Campus leagues</a:t>
-            </a:r>
-          </a:p>
-        </p:txBody>
-      </p:sp>
-      <p:sp>
-        <p:nvSpPr>
-          <p:cNvPr id="9" name="Rounded Rectangle 8"/>
-          <p:cNvSpPr/>
-          <p:nvPr/>
-        </p:nvSpPr>
-        <p:spPr>
-          <a:xfrm>
-            <a:off x="4846320" y="5440679"/>
-            <a:ext cx="6583680" cy="685800"/>
-          </a:xfrm>
-          <a:prstGeom prst="roundRect">
-            <a:avLst/>
-          </a:prstGeom>
-          <a:solidFill>
-            <a:srgbClr val="12241E"/>
-          </a:solidFill>
-          <a:ln w="12700">
-            <a:solidFill>
-              <a:srgbClr val="21D8A0"/>
-            </a:solidFill>
-          </a:ln>
-        </p:spPr>
-        <p:style>
-          <a:lnRef idx="1">
-            <a:schemeClr val="accent1"/>
-          </a:lnRef>
-          <a:fillRef idx="3">
-            <a:schemeClr val="accent1"/>
-          </a:fillRef>
-          <a:effectRef idx="2">
-            <a:schemeClr val="accent1"/>
-          </a:effectRef>
-          <a:fontRef idx="minor">
-            <a:schemeClr val="lt1"/>
-          </a:fontRef>
-        </p:style>
-        <p:txBody>
-          <a:bodyPr rtlCol="0" anchor="ctr" wrap="square" lIns="182880" tIns="91440"/>
-          <a:lstStyle/>
-          <a:p>
-            <a:pPr algn="ctr">
-              <a:defRPr sz="1300" b="1">
-                <a:solidFill>
-                  <a:srgbClr val="FFFFFF"/>
-                </a:solidFill>
-              </a:defRPr>
-            </a:pPr>
-            <a:r>
-              <a:t>Server &amp; Infrastructure  —  </a:t>
-            </a:r>
-            <a:r>
-              <a:rPr b="1">
-                <a:solidFill>
-                  <a:srgbClr val="FFB800"/>
-                </a:solidFill>
-              </a:rPr>
-              <a:t>$5,000 (10%)</a:t>
-            </a:r>
-          </a:p>
-          <a:p>
-            <a:pPr>
-              <a:defRPr sz="1050">
-                <a:solidFill>
-                  <a:srgbClr val="A3B8B0"/>
-                </a:solidFill>
-              </a:defRPr>
-            </a:pPr>
-            <a:r>
-              <a:t>PostGIS Database, Redis cluster, Map tiles, Legal &amp; Contingency</a:t>
+              <a:t>Virtual obyektlar. Real yugurish va yopiq kontur maydon hisobi yo'q.</a:t>
             </a:r>
           </a:p>
         </p:txBody>
@@ -5743,7 +5315,7 @@
               </a:defRPr>
             </a:pPr>
             <a:r>
-              <a:t>DON'T STOP — PITCH DECK</a:t>
+              <a:t>DON'T STOP — INVESTOR PITCH DECK</a:t>
             </a:r>
           </a:p>
           <a:p>
@@ -5755,7 +5327,7 @@
               </a:defRPr>
             </a:pPr>
             <a:r>
-              <a:t>Technical Execution &amp; Mobile Handoff</a:t>
+              <a:t>Monetizatsiya va Daromad Modeli</a:t>
             </a:r>
           </a:p>
         </p:txBody>
@@ -5769,7 +5341,7 @@
         <p:spPr>
           <a:xfrm>
             <a:off x="731520" y="1645920"/>
-            <a:ext cx="3383280" cy="4663440"/>
+            <a:ext cx="2468880" cy="4389120"/>
           </a:xfrm>
           <a:prstGeom prst="roundRect">
             <a:avLst/>
@@ -5798,12 +5370,38 @@
           </a:fontRef>
         </p:style>
         <p:txBody>
-          <a:bodyPr rtlCol="0" anchor="ctr" wrap="square" lIns="228600" rIns="228600" tIns="228600"/>
-          <a:lstStyle/>
-          <a:p>
-            <a:pPr algn="ctr">
+          <a:bodyPr rtlCol="0" anchor="ctr"/>
+          <a:lstStyle/>
+          <a:p>
+            <a:pPr algn="ctr"/>
+          </a:p>
+        </p:txBody>
+      </p:sp>
+      <p:sp>
+        <p:nvSpPr>
+          <p:cNvPr id="4" name="TextBox 3"/>
+          <p:cNvSpPr txBox="1"/>
+          <p:nvPr/>
+        </p:nvSpPr>
+        <p:spPr>
+          <a:xfrm>
+            <a:off x="868680" y="1783080"/>
+            <a:ext cx="2194560" cy="4114800"/>
+          </a:xfrm>
+          <a:prstGeom prst="rect">
+            <a:avLst/>
+          </a:prstGeom>
+          <a:noFill/>
+        </p:spPr>
+        <p:txBody>
+          <a:bodyPr wrap="square">
+            <a:spAutoFit/>
+          </a:bodyPr>
+          <a:lstStyle/>
+          <a:p>
+            <a:pPr>
               <a:spcAft>
-                <a:spcPts val="1400"/>
+                <a:spcPts val="600"/>
               </a:spcAft>
               <a:defRPr sz="1600" b="1">
                 <a:solidFill>
@@ -5812,33 +5410,223 @@
               </a:defRPr>
             </a:pPr>
             <a:r>
-              <a:t>💻 Fully Functional Web Stack</a:t>
+              <a:t>01. BATTLE PASS</a:t>
             </a:r>
           </a:p>
           <a:p>
             <a:pPr>
               <a:defRPr sz="1300">
                 <a:solidFill>
-                  <a:srgbClr val="FFFFFF"/>
-                </a:solidFill>
-              </a:defRPr>
-            </a:pPr>
-            <a:r>
-              <a:t>FastAPI Python backend + PostGIS spatial database + MapLibre GL frontend engine already 100% built and verified with 105 automated unit/integration tests.</a:t>
-            </a:r>
-          </a:p>
-        </p:txBody>
-      </p:sp>
-      <p:sp>
-        <p:nvSpPr>
-          <p:cNvPr id="4" name="Rounded Rectangle 3"/>
+                  <a:srgbClr val="A3B8B0"/>
+                </a:solidFill>
+              </a:defRPr>
+            </a:pPr>
+            <a:r>
+              <a:t>Kosmetik izlar, gerb ramkalari va xarita mavzulari ($4.99 / oy).</a:t>
+            </a:r>
+          </a:p>
+        </p:txBody>
+      </p:sp>
+      <p:sp>
+        <p:nvSpPr>
+          <p:cNvPr id="5" name="Rounded Rectangle 4"/>
           <p:cNvSpPr/>
           <p:nvPr/>
         </p:nvSpPr>
         <p:spPr>
           <a:xfrm>
-            <a:off x="4389120" y="1645920"/>
-            <a:ext cx="3383280" cy="4663440"/>
+            <a:off x="3474720" y="1645920"/>
+            <a:ext cx="2468880" cy="4389120"/>
+          </a:xfrm>
+          <a:prstGeom prst="roundRect">
+            <a:avLst/>
+          </a:prstGeom>
+          <a:solidFill>
+            <a:srgbClr val="12241E"/>
+          </a:solidFill>
+          <a:ln w="19050">
+            <a:solidFill>
+              <a:srgbClr val="21D8A0"/>
+            </a:solidFill>
+          </a:ln>
+        </p:spPr>
+        <p:style>
+          <a:lnRef idx="1">
+            <a:schemeClr val="accent1"/>
+          </a:lnRef>
+          <a:fillRef idx="3">
+            <a:schemeClr val="accent1"/>
+          </a:fillRef>
+          <a:effectRef idx="2">
+            <a:schemeClr val="accent1"/>
+          </a:effectRef>
+          <a:fontRef idx="minor">
+            <a:schemeClr val="lt1"/>
+          </a:fontRef>
+        </p:style>
+        <p:txBody>
+          <a:bodyPr rtlCol="0" anchor="ctr"/>
+          <a:lstStyle/>
+          <a:p>
+            <a:pPr algn="ctr"/>
+          </a:p>
+        </p:txBody>
+      </p:sp>
+      <p:sp>
+        <p:nvSpPr>
+          <p:cNvPr id="6" name="TextBox 5"/>
+          <p:cNvSpPr txBox="1"/>
+          <p:nvPr/>
+        </p:nvSpPr>
+        <p:spPr>
+          <a:xfrm>
+            <a:off x="3611880" y="1783080"/>
+            <a:ext cx="2194560" cy="4114800"/>
+          </a:xfrm>
+          <a:prstGeom prst="rect">
+            <a:avLst/>
+          </a:prstGeom>
+          <a:noFill/>
+        </p:spPr>
+        <p:txBody>
+          <a:bodyPr wrap="square">
+            <a:spAutoFit/>
+          </a:bodyPr>
+          <a:lstStyle/>
+          <a:p>
+            <a:pPr>
+              <a:spcAft>
+                <a:spcPts val="600"/>
+              </a:spcAft>
+              <a:defRPr sz="1600" b="1">
+                <a:solidFill>
+                  <a:srgbClr val="21D8A0"/>
+                </a:solidFill>
+              </a:defRPr>
+            </a:pPr>
+            <a:r>
+              <a:t>02. MIKROTRANSAKSIYA</a:t>
+            </a:r>
+          </a:p>
+          <a:p>
+            <a:pPr>
+              <a:defRPr sz="1300">
+                <a:solidFill>
+                  <a:srgbClr val="A3B8B0"/>
+                </a:solidFill>
+              </a:defRPr>
+            </a:pPr>
+            <a:r>
+              <a:t>Avatar, gildiya tokenlari va nickname pass ($0.99 – $9.99).</a:t>
+            </a:r>
+          </a:p>
+        </p:txBody>
+      </p:sp>
+      <p:sp>
+        <p:nvSpPr>
+          <p:cNvPr id="7" name="Rounded Rectangle 6"/>
+          <p:cNvSpPr/>
+          <p:nvPr/>
+        </p:nvSpPr>
+        <p:spPr>
+          <a:xfrm>
+            <a:off x="6217920" y="1645920"/>
+            <a:ext cx="2468880" cy="4389120"/>
+          </a:xfrm>
+          <a:prstGeom prst="roundRect">
+            <a:avLst/>
+          </a:prstGeom>
+          <a:solidFill>
+            <a:srgbClr val="12241E"/>
+          </a:solidFill>
+          <a:ln w="19050">
+            <a:solidFill>
+              <a:srgbClr val="FFB800"/>
+            </a:solidFill>
+          </a:ln>
+        </p:spPr>
+        <p:style>
+          <a:lnRef idx="1">
+            <a:schemeClr val="accent1"/>
+          </a:lnRef>
+          <a:fillRef idx="3">
+            <a:schemeClr val="accent1"/>
+          </a:fillRef>
+          <a:effectRef idx="2">
+            <a:schemeClr val="accent1"/>
+          </a:effectRef>
+          <a:fontRef idx="minor">
+            <a:schemeClr val="lt1"/>
+          </a:fontRef>
+        </p:style>
+        <p:txBody>
+          <a:bodyPr rtlCol="0" anchor="ctr"/>
+          <a:lstStyle/>
+          <a:p>
+            <a:pPr algn="ctr"/>
+          </a:p>
+        </p:txBody>
+      </p:sp>
+      <p:sp>
+        <p:nvSpPr>
+          <p:cNvPr id="8" name="TextBox 7"/>
+          <p:cNvSpPr txBox="1"/>
+          <p:nvPr/>
+        </p:nvSpPr>
+        <p:spPr>
+          <a:xfrm>
+            <a:off x="6355080" y="1783080"/>
+            <a:ext cx="2194560" cy="4114800"/>
+          </a:xfrm>
+          <a:prstGeom prst="rect">
+            <a:avLst/>
+          </a:prstGeom>
+          <a:noFill/>
+        </p:spPr>
+        <p:txBody>
+          <a:bodyPr wrap="square">
+            <a:spAutoFit/>
+          </a:bodyPr>
+          <a:lstStyle/>
+          <a:p>
+            <a:pPr>
+              <a:spcAft>
+                <a:spcPts val="600"/>
+              </a:spcAft>
+              <a:defRPr sz="1600" b="1">
+                <a:solidFill>
+                  <a:srgbClr val="FFB800"/>
+                </a:solidFill>
+              </a:defRPr>
+            </a:pPr>
+            <a:r>
+              <a:t>03. BREND HAMKORLIGI</a:t>
+            </a:r>
+          </a:p>
+          <a:p>
+            <a:pPr>
+              <a:defRPr sz="1300">
+                <a:solidFill>
+                  <a:srgbClr val="A3B8B0"/>
+                </a:solidFill>
+              </a:defRPr>
+            </a:pPr>
+            <a:r>
+              <a:t>Homiy hududlar va sport kafolari turnirlari ($2K – $10K / event).</a:t>
+            </a:r>
+          </a:p>
+        </p:txBody>
+      </p:sp>
+      <p:sp>
+        <p:nvSpPr>
+          <p:cNvPr id="9" name="Rounded Rectangle 8"/>
+          <p:cNvSpPr/>
+          <p:nvPr/>
+        </p:nvSpPr>
+        <p:spPr>
+          <a:xfrm>
+            <a:off x="8961120" y="1645920"/>
+            <a:ext cx="2468880" cy="4389120"/>
           </a:xfrm>
           <a:prstGeom prst="roundRect">
             <a:avLst/>
@@ -5867,12 +5655,38 @@
           </a:fontRef>
         </p:style>
         <p:txBody>
-          <a:bodyPr rtlCol="0" anchor="ctr" wrap="square" lIns="228600" rIns="228600" tIns="228600"/>
-          <a:lstStyle/>
-          <a:p>
-            <a:pPr algn="ctr">
+          <a:bodyPr rtlCol="0" anchor="ctr"/>
+          <a:lstStyle/>
+          <a:p>
+            <a:pPr algn="ctr"/>
+          </a:p>
+        </p:txBody>
+      </p:sp>
+      <p:sp>
+        <p:nvSpPr>
+          <p:cNvPr id="10" name="TextBox 9"/>
+          <p:cNvSpPr txBox="1"/>
+          <p:nvPr/>
+        </p:nvSpPr>
+        <p:spPr>
+          <a:xfrm>
+            <a:off x="9098280" y="1783080"/>
+            <a:ext cx="2194560" cy="4114800"/>
+          </a:xfrm>
+          <a:prstGeom prst="rect">
+            <a:avLst/>
+          </a:prstGeom>
+          <a:noFill/>
+        </p:spPr>
+        <p:txBody>
+          <a:bodyPr wrap="square">
+            <a:spAutoFit/>
+          </a:bodyPr>
+          <a:lstStyle/>
+          <a:p>
+            <a:pPr>
               <a:spcAft>
-                <a:spcPts val="1400"/>
+                <a:spcPts val="600"/>
               </a:spcAft>
               <a:defRPr sz="1600" b="1">
                 <a:solidFill>
@@ -5881,88 +5695,19 @@
               </a:defRPr>
             </a:pPr>
             <a:r>
-              <a:t>📱 Turnkey Mobile APK Pipeline</a:t>
+              <a:t>04. B2B ANALITIKA</a:t>
             </a:r>
           </a:p>
           <a:p>
             <a:pPr>
               <a:defRPr sz="1300">
                 <a:solidFill>
-                  <a:srgbClr val="FFFFFF"/>
-                </a:solidFill>
-              </a:defRPr>
-            </a:pPr>
-            <a:r>
-              <a:t>Frontend built with React + Vite + Capacitor wrapper pipeline, allowing instant mobile APK/AAB builds for Android Play Store and Apple App Store.</a:t>
-            </a:r>
-          </a:p>
-        </p:txBody>
-      </p:sp>
-      <p:sp>
-        <p:nvSpPr>
-          <p:cNvPr id="5" name="Rounded Rectangle 4"/>
-          <p:cNvSpPr/>
-          <p:nvPr/>
-        </p:nvSpPr>
-        <p:spPr>
-          <a:xfrm>
-            <a:off x="8046720" y="1645920"/>
-            <a:ext cx="3383280" cy="4663440"/>
-          </a:xfrm>
-          <a:prstGeom prst="roundRect">
-            <a:avLst/>
-          </a:prstGeom>
-          <a:solidFill>
-            <a:srgbClr val="12241E"/>
-          </a:solidFill>
-          <a:ln w="19050">
-            <a:solidFill>
-              <a:srgbClr val="FFB800"/>
-            </a:solidFill>
-          </a:ln>
-        </p:spPr>
-        <p:style>
-          <a:lnRef idx="1">
-            <a:schemeClr val="accent1"/>
-          </a:lnRef>
-          <a:fillRef idx="3">
-            <a:schemeClr val="accent1"/>
-          </a:fillRef>
-          <a:effectRef idx="2">
-            <a:schemeClr val="accent1"/>
-          </a:effectRef>
-          <a:fontRef idx="minor">
-            <a:schemeClr val="lt1"/>
-          </a:fontRef>
-        </p:style>
-        <p:txBody>
-          <a:bodyPr rtlCol="0" anchor="ctr" wrap="square" lIns="228600" rIns="228600" tIns="228600"/>
-          <a:lstStyle/>
-          <a:p>
-            <a:pPr algn="ctr">
-              <a:spcAft>
-                <a:spcPts val="1400"/>
-              </a:spcAft>
-              <a:defRPr sz="1600" b="1">
-                <a:solidFill>
-                  <a:srgbClr val="FFB800"/>
-                </a:solidFill>
-              </a:defRPr>
-            </a:pPr>
-            <a:r>
-              <a:t>🔒 Production Security &amp; Quality</a:t>
-            </a:r>
-          </a:p>
-          <a:p>
-            <a:pPr>
-              <a:defRPr sz="1300">
-                <a:solidFill>
-                  <a:srgbClr val="FFFFFF"/>
-                </a:solidFill>
-              </a:defRPr>
-            </a:pPr>
-            <a:r>
-              <a:t>Strict 8-digit numeric Player ID system, 200m Privacy Radius protection, spatial building exclusions, and multi-language engine (QQ, UZ, KK, TR, EN).</a:t>
+                  <a:srgbClr val="A3B8B0"/>
+                </a:solidFill>
+              </a:defRPr>
+            </a:pPr>
+            <a:r>
+              <a:t>Anonimlashtirilgan shahar harakati insightlari (Pilotdan keyin).</a:t>
             </a:r>
           </a:p>
         </p:txBody>
@@ -5995,14 +5740,64 @@
       <p:grpSpPr/>
       <p:sp>
         <p:nvSpPr>
-          <p:cNvPr id="2" name="Rounded Rectangle 1"/>
+          <p:cNvPr id="2" name="TextBox 1"/>
+          <p:cNvSpPr txBox="1"/>
+          <p:nvPr/>
+        </p:nvSpPr>
+        <p:spPr>
+          <a:xfrm>
+            <a:off x="731520" y="365760"/>
+            <a:ext cx="10698480" cy="1005840"/>
+          </a:xfrm>
+          <a:prstGeom prst="rect">
+            <a:avLst/>
+          </a:prstGeom>
+          <a:noFill/>
+        </p:spPr>
+        <p:txBody>
+          <a:bodyPr wrap="square" lIns="0" tIns="0" rIns="0" bIns="0">
+            <a:spAutoFit/>
+          </a:bodyPr>
+          <a:lstStyle/>
+          <a:p>
+            <a:pPr>
+              <a:spcAft>
+                <a:spcPts val="400"/>
+              </a:spcAft>
+              <a:defRPr sz="1100" b="1">
+                <a:solidFill>
+                  <a:srgbClr val="21D8A0"/>
+                </a:solidFill>
+              </a:defRPr>
+            </a:pPr>
+            <a:r>
+              <a:t>DON'T STOP — INVESTOR PITCH DECK</a:t>
+            </a:r>
+          </a:p>
+          <a:p>
+            <a:pPr>
+              <a:defRPr sz="2600" b="1">
+                <a:solidFill>
+                  <a:srgbClr val="FFFFFF"/>
+                </a:solidFill>
+              </a:defRPr>
+            </a:pPr>
+            <a:r>
+              <a:t>3 Yillik O'sish Rejasi (Growth Roadmap)</a:t>
+            </a:r>
+          </a:p>
+        </p:txBody>
+      </p:sp>
+      <p:sp>
+        <p:nvSpPr>
+          <p:cNvPr id="3" name="Rounded Rectangle 2"/>
           <p:cNvSpPr/>
           <p:nvPr/>
         </p:nvSpPr>
         <p:spPr>
           <a:xfrm>
-            <a:off x="1371600" y="1371600"/>
-            <a:ext cx="9448495" cy="4114800"/>
+            <a:off x="731520" y="1645920"/>
+            <a:ext cx="2468880" cy="4389120"/>
           </a:xfrm>
           <a:prstGeom prst="roundRect">
             <a:avLst/>
@@ -6010,7 +5805,7 @@
           <a:solidFill>
             <a:srgbClr val="12241E"/>
           </a:solidFill>
-          <a:ln w="25400">
+          <a:ln w="19050">
             <a:solidFill>
               <a:srgbClr val="21D8A0"/>
             </a:solidFill>
@@ -6031,63 +5826,990 @@
           </a:fontRef>
         </p:style>
         <p:txBody>
-          <a:bodyPr rtlCol="0" anchor="ctr" wrap="square" lIns="457200" rIns="457200" tIns="457200"/>
-          <a:lstStyle/>
-          <a:p>
-            <a:pPr algn="ctr">
+          <a:bodyPr rtlCol="0" anchor="ctr"/>
+          <a:lstStyle/>
+          <a:p>
+            <a:pPr algn="ctr"/>
+          </a:p>
+        </p:txBody>
+      </p:sp>
+      <p:sp>
+        <p:nvSpPr>
+          <p:cNvPr id="4" name="TextBox 3"/>
+          <p:cNvSpPr txBox="1"/>
+          <p:nvPr/>
+        </p:nvSpPr>
+        <p:spPr>
+          <a:xfrm>
+            <a:off x="868680" y="1783080"/>
+            <a:ext cx="2194560" cy="4114800"/>
+          </a:xfrm>
+          <a:prstGeom prst="rect">
+            <a:avLst/>
+          </a:prstGeom>
+          <a:noFill/>
+        </p:spPr>
+        <p:txBody>
+          <a:bodyPr wrap="square">
+            <a:spAutoFit/>
+          </a:bodyPr>
+          <a:lstStyle/>
+          <a:p>
+            <a:pPr>
               <a:spcAft>
-                <a:spcPts val="1200"/>
+                <a:spcPts val="600"/>
               </a:spcAft>
-              <a:defRPr sz="2800" b="1">
+              <a:defRPr sz="1600" b="1">
                 <a:solidFill>
                   <a:srgbClr val="21D8A0"/>
                 </a:solidFill>
               </a:defRPr>
             </a:pPr>
             <a:r>
-              <a:t>JOIN THE REAL-WORLD GAMING REVOLUTION</a:t>
-            </a:r>
-          </a:p>
+              <a:t>3 OY (Pilot)</a:t>
+            </a:r>
+          </a:p>
+          <a:p>
+            <a:pPr>
+              <a:defRPr sz="1300">
+                <a:solidFill>
+                  <a:srgbClr val="A3B8B0"/>
+                </a:solidFill>
+              </a:defRPr>
+            </a:pPr>
+            <a:r>
+              <a:t>Nukus va Toshkent (15K foydalanuvchi)</a:t>
+            </a:r>
+          </a:p>
+        </p:txBody>
+      </p:sp>
+      <p:sp>
+        <p:nvSpPr>
+          <p:cNvPr id="5" name="Rounded Rectangle 4"/>
+          <p:cNvSpPr/>
+          <p:nvPr/>
+        </p:nvSpPr>
+        <p:spPr>
+          <a:xfrm>
+            <a:off x="3474720" y="1645920"/>
+            <a:ext cx="2468880" cy="4389120"/>
+          </a:xfrm>
+          <a:prstGeom prst="roundRect">
+            <a:avLst/>
+          </a:prstGeom>
+          <a:solidFill>
+            <a:srgbClr val="12241E"/>
+          </a:solidFill>
+          <a:ln w="19050">
+            <a:solidFill>
+              <a:srgbClr val="21D8A0"/>
+            </a:solidFill>
+          </a:ln>
+        </p:spPr>
+        <p:style>
+          <a:lnRef idx="1">
+            <a:schemeClr val="accent1"/>
+          </a:lnRef>
+          <a:fillRef idx="3">
+            <a:schemeClr val="accent1"/>
+          </a:fillRef>
+          <a:effectRef idx="2">
+            <a:schemeClr val="accent1"/>
+          </a:effectRef>
+          <a:fontRef idx="minor">
+            <a:schemeClr val="lt1"/>
+          </a:fontRef>
+        </p:style>
+        <p:txBody>
+          <a:bodyPr rtlCol="0" anchor="ctr"/>
+          <a:lstStyle/>
+          <a:p>
+            <a:pPr algn="ctr"/>
+          </a:p>
+        </p:txBody>
+      </p:sp>
+      <p:sp>
+        <p:nvSpPr>
+          <p:cNvPr id="6" name="TextBox 5"/>
+          <p:cNvSpPr txBox="1"/>
+          <p:nvPr/>
+        </p:nvSpPr>
+        <p:spPr>
+          <a:xfrm>
+            <a:off x="3611880" y="1783080"/>
+            <a:ext cx="2194560" cy="4114800"/>
+          </a:xfrm>
+          <a:prstGeom prst="rect">
+            <a:avLst/>
+          </a:prstGeom>
+          <a:noFill/>
+        </p:spPr>
+        <p:txBody>
+          <a:bodyPr wrap="square">
+            <a:spAutoFit/>
+          </a:bodyPr>
+          <a:lstStyle/>
           <a:p>
             <a:pPr>
               <a:spcAft>
-                <a:spcPts val="2400"/>
+                <a:spcPts val="600"/>
               </a:spcAft>
-              <a:defRPr sz="1600">
+              <a:defRPr sz="1600" b="1">
+                <a:solidFill>
+                  <a:srgbClr val="21D8A0"/>
+                </a:solidFill>
+              </a:defRPr>
+            </a:pPr>
+            <a:r>
+              <a:t>6 OY (Regional)</a:t>
+            </a:r>
+          </a:p>
+          <a:p>
+            <a:pPr>
+              <a:defRPr sz="1300">
+                <a:solidFill>
+                  <a:srgbClr val="A3B8B0"/>
+                </a:solidFill>
+              </a:defRPr>
+            </a:pPr>
+            <a:r>
+              <a:t>Samarqand, Olmaota, Chimkent (75K foydalanuvchi)</a:t>
+            </a:r>
+          </a:p>
+        </p:txBody>
+      </p:sp>
+      <p:sp>
+        <p:nvSpPr>
+          <p:cNvPr id="7" name="Rounded Rectangle 6"/>
+          <p:cNvSpPr/>
+          <p:nvPr/>
+        </p:nvSpPr>
+        <p:spPr>
+          <a:xfrm>
+            <a:off x="6217920" y="1645920"/>
+            <a:ext cx="2468880" cy="4389120"/>
+          </a:xfrm>
+          <a:prstGeom prst="roundRect">
+            <a:avLst/>
+          </a:prstGeom>
+          <a:solidFill>
+            <a:srgbClr val="12241E"/>
+          </a:solidFill>
+          <a:ln w="19050">
+            <a:solidFill>
+              <a:srgbClr val="21D8A0"/>
+            </a:solidFill>
+          </a:ln>
+        </p:spPr>
+        <p:style>
+          <a:lnRef idx="1">
+            <a:schemeClr val="accent1"/>
+          </a:lnRef>
+          <a:fillRef idx="3">
+            <a:schemeClr val="accent1"/>
+          </a:fillRef>
+          <a:effectRef idx="2">
+            <a:schemeClr val="accent1"/>
+          </a:effectRef>
+          <a:fontRef idx="minor">
+            <a:schemeClr val="lt1"/>
+          </a:fontRef>
+        </p:style>
+        <p:txBody>
+          <a:bodyPr rtlCol="0" anchor="ctr"/>
+          <a:lstStyle/>
+          <a:p>
+            <a:pPr algn="ctr"/>
+          </a:p>
+        </p:txBody>
+      </p:sp>
+      <p:sp>
+        <p:nvSpPr>
+          <p:cNvPr id="8" name="TextBox 7"/>
+          <p:cNvSpPr txBox="1"/>
+          <p:nvPr/>
+        </p:nvSpPr>
+        <p:spPr>
+          <a:xfrm>
+            <a:off x="6355080" y="1783080"/>
+            <a:ext cx="2194560" cy="4114800"/>
+          </a:xfrm>
+          <a:prstGeom prst="rect">
+            <a:avLst/>
+          </a:prstGeom>
+          <a:noFill/>
+        </p:spPr>
+        <p:txBody>
+          <a:bodyPr wrap="square">
+            <a:spAutoFit/>
+          </a:bodyPr>
+          <a:lstStyle/>
+          <a:p>
+            <a:pPr>
+              <a:spcAft>
+                <a:spcPts val="600"/>
+              </a:spcAft>
+              <a:defRPr sz="1600" b="1">
+                <a:solidFill>
+                  <a:srgbClr val="21D8A0"/>
+                </a:solidFill>
+              </a:defRPr>
+            </a:pPr>
+            <a:r>
+              <a:t>1 YIL (Xalqaro)</a:t>
+            </a:r>
+          </a:p>
+          <a:p>
+            <a:pPr>
+              <a:defRPr sz="1300">
+                <a:solidFill>
+                  <a:srgbClr val="A3B8B0"/>
+                </a:solidFill>
+              </a:defRPr>
+            </a:pPr>
+            <a:r>
+              <a:t>Istanbul, Astana, Boku (300K foydalanuvchi)</a:t>
+            </a:r>
+          </a:p>
+        </p:txBody>
+      </p:sp>
+      <p:sp>
+        <p:nvSpPr>
+          <p:cNvPr id="9" name="Rounded Rectangle 8"/>
+          <p:cNvSpPr/>
+          <p:nvPr/>
+        </p:nvSpPr>
+        <p:spPr>
+          <a:xfrm>
+            <a:off x="8961120" y="1645920"/>
+            <a:ext cx="2468880" cy="4389120"/>
+          </a:xfrm>
+          <a:prstGeom prst="roundRect">
+            <a:avLst/>
+          </a:prstGeom>
+          <a:solidFill>
+            <a:srgbClr val="12241E"/>
+          </a:solidFill>
+          <a:ln w="19050">
+            <a:solidFill>
+              <a:srgbClr val="FFB800"/>
+            </a:solidFill>
+          </a:ln>
+        </p:spPr>
+        <p:style>
+          <a:lnRef idx="1">
+            <a:schemeClr val="accent1"/>
+          </a:lnRef>
+          <a:fillRef idx="3">
+            <a:schemeClr val="accent1"/>
+          </a:fillRef>
+          <a:effectRef idx="2">
+            <a:schemeClr val="accent1"/>
+          </a:effectRef>
+          <a:fontRef idx="minor">
+            <a:schemeClr val="lt1"/>
+          </a:fontRef>
+        </p:style>
+        <p:txBody>
+          <a:bodyPr rtlCol="0" anchor="ctr"/>
+          <a:lstStyle/>
+          <a:p>
+            <a:pPr algn="ctr"/>
+          </a:p>
+        </p:txBody>
+      </p:sp>
+      <p:sp>
+        <p:nvSpPr>
+          <p:cNvPr id="10" name="TextBox 9"/>
+          <p:cNvSpPr txBox="1"/>
+          <p:nvPr/>
+        </p:nvSpPr>
+        <p:spPr>
+          <a:xfrm>
+            <a:off x="9098280" y="1783080"/>
+            <a:ext cx="2194560" cy="4114800"/>
+          </a:xfrm>
+          <a:prstGeom prst="rect">
+            <a:avLst/>
+          </a:prstGeom>
+          <a:noFill/>
+        </p:spPr>
+        <p:txBody>
+          <a:bodyPr wrap="square">
+            <a:spAutoFit/>
+          </a:bodyPr>
+          <a:lstStyle/>
+          <a:p>
+            <a:pPr>
+              <a:spcAft>
+                <a:spcPts val="600"/>
+              </a:spcAft>
+              <a:defRPr sz="1600" b="1">
+                <a:solidFill>
+                  <a:srgbClr val="FFB800"/>
+                </a:solidFill>
+              </a:defRPr>
+            </a:pPr>
+            <a:r>
+              <a:t>3 YIL (Ekotizim)</a:t>
+            </a:r>
+          </a:p>
+          <a:p>
+            <a:pPr>
+              <a:defRPr sz="1300">
+                <a:solidFill>
+                  <a:srgbClr val="A3B8B0"/>
+                </a:solidFill>
+              </a:defRPr>
+            </a:pPr>
+            <a:r>
+              <a:t>Global B2B homiylar ($4M+ yillik daromad)</a:t>
+            </a:r>
+          </a:p>
+        </p:txBody>
+      </p:sp>
+    </p:spTree>
+  </p:cSld>
+  <p:clrMapOvr>
+    <a:masterClrMapping/>
+  </p:clrMapOvr>
+</p:sld>
+</file>
+
+<file path=ppt/slides/slide9.xml><?xml version="1.0" encoding="utf-8"?>
+<p:sld xmlns:a="http://schemas.openxmlformats.org/drawingml/2006/main" xmlns:p="http://schemas.openxmlformats.org/presentationml/2006/main" xmlns:r="http://schemas.openxmlformats.org/officeDocument/2006/relationships">
+  <p:cSld>
+    <p:bg>
+      <p:bgPr>
+        <a:solidFill>
+          <a:srgbClr val="0B1512"/>
+        </a:solidFill>
+        <a:effectLst/>
+      </p:bgPr>
+    </p:bg>
+    <p:spTree>
+      <p:nvGrpSpPr>
+        <p:cNvPr id="1" name=""/>
+        <p:cNvGrpSpPr/>
+        <p:nvPr/>
+      </p:nvGrpSpPr>
+      <p:grpSpPr/>
+      <p:sp>
+        <p:nvSpPr>
+          <p:cNvPr id="2" name="TextBox 1"/>
+          <p:cNvSpPr txBox="1"/>
+          <p:nvPr/>
+        </p:nvSpPr>
+        <p:spPr>
+          <a:xfrm>
+            <a:off x="731520" y="365760"/>
+            <a:ext cx="10698480" cy="1005840"/>
+          </a:xfrm>
+          <a:prstGeom prst="rect">
+            <a:avLst/>
+          </a:prstGeom>
+          <a:noFill/>
+        </p:spPr>
+        <p:txBody>
+          <a:bodyPr wrap="square" lIns="0" tIns="0" rIns="0" bIns="0">
+            <a:spAutoFit/>
+          </a:bodyPr>
+          <a:lstStyle/>
+          <a:p>
+            <a:pPr>
+              <a:spcAft>
+                <a:spcPts val="400"/>
+              </a:spcAft>
+              <a:defRPr sz="1100" b="1">
+                <a:solidFill>
+                  <a:srgbClr val="21D8A0"/>
+                </a:solidFill>
+              </a:defRPr>
+            </a:pPr>
+            <a:r>
+              <a:t>DON'T STOP — INVESTOR PITCH DECK</a:t>
+            </a:r>
+          </a:p>
+          <a:p>
+            <a:pPr>
+              <a:defRPr sz="2600" b="1">
                 <a:solidFill>
                   <a:srgbClr val="FFFFFF"/>
                 </a:solidFill>
               </a:defRPr>
             </a:pPr>
             <a:r>
-              <a:t>Don't Stop turns cities into live interactive gaming battlegrounds.</a:t>
-            </a:r>
-          </a:p>
+              <a:t>$50 000 Pre-Seed Byudjet Taqsimoti</a:t>
+            </a:r>
+          </a:p>
+        </p:txBody>
+      </p:sp>
+      <p:sp>
+        <p:nvSpPr>
+          <p:cNvPr id="3" name="Rounded Rectangle 2"/>
+          <p:cNvSpPr/>
+          <p:nvPr/>
+        </p:nvSpPr>
+        <p:spPr>
+          <a:xfrm>
+            <a:off x="731520" y="1645920"/>
+            <a:ext cx="3291840" cy="2011680"/>
+          </a:xfrm>
+          <a:prstGeom prst="roundRect">
+            <a:avLst/>
+          </a:prstGeom>
+          <a:solidFill>
+            <a:srgbClr val="12241E"/>
+          </a:solidFill>
+          <a:ln w="19050">
+            <a:solidFill>
+              <a:srgbClr val="21D8A0"/>
+            </a:solidFill>
+          </a:ln>
+        </p:spPr>
+        <p:style>
+          <a:lnRef idx="1">
+            <a:schemeClr val="accent1"/>
+          </a:lnRef>
+          <a:fillRef idx="3">
+            <a:schemeClr val="accent1"/>
+          </a:fillRef>
+          <a:effectRef idx="2">
+            <a:schemeClr val="accent1"/>
+          </a:effectRef>
+          <a:fontRef idx="minor">
+            <a:schemeClr val="lt1"/>
+          </a:fontRef>
+        </p:style>
+        <p:txBody>
+          <a:bodyPr rtlCol="0" anchor="ctr"/>
+          <a:lstStyle/>
+          <a:p>
+            <a:pPr algn="ctr"/>
+          </a:p>
+        </p:txBody>
+      </p:sp>
+      <p:sp>
+        <p:nvSpPr>
+          <p:cNvPr id="4" name="TextBox 3"/>
+          <p:cNvSpPr txBox="1"/>
+          <p:nvPr/>
+        </p:nvSpPr>
+        <p:spPr>
+          <a:xfrm>
+            <a:off x="868680" y="1783080"/>
+            <a:ext cx="3017520" cy="1737360"/>
+          </a:xfrm>
+          <a:prstGeom prst="rect">
+            <a:avLst/>
+          </a:prstGeom>
+          <a:noFill/>
+        </p:spPr>
+        <p:txBody>
+          <a:bodyPr wrap="square">
+            <a:spAutoFit/>
+          </a:bodyPr>
+          <a:lstStyle/>
           <a:p>
             <a:pPr>
               <a:spcAft>
-                <a:spcPts val="800"/>
+                <a:spcPts val="600"/>
               </a:spcAft>
-              <a:defRPr sz="1800" b="1">
+              <a:defRPr sz="1600" b="1">
+                <a:solidFill>
+                  <a:srgbClr val="21D8A0"/>
+                </a:solidFill>
+              </a:defRPr>
+            </a:pPr>
+            <a:r>
+              <a:t>Backend &amp; Spatial API</a:t>
+            </a:r>
+          </a:p>
+          <a:p>
+            <a:pPr>
+              <a:defRPr sz="1300">
+                <a:solidFill>
+                  <a:srgbClr val="A3B8B0"/>
+                </a:solidFill>
+              </a:defRPr>
+            </a:pPr>
+            <a:r>
+              <a:t>$12,000 (24%)</a:t>
+            </a:r>
+          </a:p>
+        </p:txBody>
+      </p:sp>
+      <p:sp>
+        <p:nvSpPr>
+          <p:cNvPr id="5" name="Rounded Rectangle 4"/>
+          <p:cNvSpPr/>
+          <p:nvPr/>
+        </p:nvSpPr>
+        <p:spPr>
+          <a:xfrm>
+            <a:off x="4389120" y="1645920"/>
+            <a:ext cx="3291840" cy="2011680"/>
+          </a:xfrm>
+          <a:prstGeom prst="roundRect">
+            <a:avLst/>
+          </a:prstGeom>
+          <a:solidFill>
+            <a:srgbClr val="12241E"/>
+          </a:solidFill>
+          <a:ln w="19050">
+            <a:solidFill>
+              <a:srgbClr val="21D8A0"/>
+            </a:solidFill>
+          </a:ln>
+        </p:spPr>
+        <p:style>
+          <a:lnRef idx="1">
+            <a:schemeClr val="accent1"/>
+          </a:lnRef>
+          <a:fillRef idx="3">
+            <a:schemeClr val="accent1"/>
+          </a:fillRef>
+          <a:effectRef idx="2">
+            <a:schemeClr val="accent1"/>
+          </a:effectRef>
+          <a:fontRef idx="minor">
+            <a:schemeClr val="lt1"/>
+          </a:fontRef>
+        </p:style>
+        <p:txBody>
+          <a:bodyPr rtlCol="0" anchor="ctr"/>
+          <a:lstStyle/>
+          <a:p>
+            <a:pPr algn="ctr"/>
+          </a:p>
+        </p:txBody>
+      </p:sp>
+      <p:sp>
+        <p:nvSpPr>
+          <p:cNvPr id="6" name="TextBox 5"/>
+          <p:cNvSpPr txBox="1"/>
+          <p:nvPr/>
+        </p:nvSpPr>
+        <p:spPr>
+          <a:xfrm>
+            <a:off x="4526280" y="1783080"/>
+            <a:ext cx="3017520" cy="1737360"/>
+          </a:xfrm>
+          <a:prstGeom prst="rect">
+            <a:avLst/>
+          </a:prstGeom>
+          <a:noFill/>
+        </p:spPr>
+        <p:txBody>
+          <a:bodyPr wrap="square">
+            <a:spAutoFit/>
+          </a:bodyPr>
+          <a:lstStyle/>
+          <a:p>
+            <a:pPr>
+              <a:spcAft>
+                <a:spcPts val="600"/>
+              </a:spcAft>
+              <a:defRPr sz="1600" b="1">
+                <a:solidFill>
+                  <a:srgbClr val="21D8A0"/>
+                </a:solidFill>
+              </a:defRPr>
+            </a:pPr>
+            <a:r>
+              <a:t>Frontend &amp; Mobile</a:t>
+            </a:r>
+          </a:p>
+          <a:p>
+            <a:pPr>
+              <a:defRPr sz="1300">
+                <a:solidFill>
+                  <a:srgbClr val="A3B8B0"/>
+                </a:solidFill>
+              </a:defRPr>
+            </a:pPr>
+            <a:r>
+              <a:t>$10,000 (20%)</a:t>
+            </a:r>
+          </a:p>
+        </p:txBody>
+      </p:sp>
+      <p:sp>
+        <p:nvSpPr>
+          <p:cNvPr id="7" name="Rounded Rectangle 6"/>
+          <p:cNvSpPr/>
+          <p:nvPr/>
+        </p:nvSpPr>
+        <p:spPr>
+          <a:xfrm>
+            <a:off x="8046720" y="1645920"/>
+            <a:ext cx="3291840" cy="2011680"/>
+          </a:xfrm>
+          <a:prstGeom prst="roundRect">
+            <a:avLst/>
+          </a:prstGeom>
+          <a:solidFill>
+            <a:srgbClr val="12241E"/>
+          </a:solidFill>
+          <a:ln w="19050">
+            <a:solidFill>
+              <a:srgbClr val="21D8A0"/>
+            </a:solidFill>
+          </a:ln>
+        </p:spPr>
+        <p:style>
+          <a:lnRef idx="1">
+            <a:schemeClr val="accent1"/>
+          </a:lnRef>
+          <a:fillRef idx="3">
+            <a:schemeClr val="accent1"/>
+          </a:fillRef>
+          <a:effectRef idx="2">
+            <a:schemeClr val="accent1"/>
+          </a:effectRef>
+          <a:fontRef idx="minor">
+            <a:schemeClr val="lt1"/>
+          </a:fontRef>
+        </p:style>
+        <p:txBody>
+          <a:bodyPr rtlCol="0" anchor="ctr"/>
+          <a:lstStyle/>
+          <a:p>
+            <a:pPr algn="ctr"/>
+          </a:p>
+        </p:txBody>
+      </p:sp>
+      <p:sp>
+        <p:nvSpPr>
+          <p:cNvPr id="8" name="TextBox 7"/>
+          <p:cNvSpPr txBox="1"/>
+          <p:nvPr/>
+        </p:nvSpPr>
+        <p:spPr>
+          <a:xfrm>
+            <a:off x="8183880" y="1783080"/>
+            <a:ext cx="3017520" cy="1737360"/>
+          </a:xfrm>
+          <a:prstGeom prst="rect">
+            <a:avLst/>
+          </a:prstGeom>
+          <a:noFill/>
+        </p:spPr>
+        <p:txBody>
+          <a:bodyPr wrap="square">
+            <a:spAutoFit/>
+          </a:bodyPr>
+          <a:lstStyle/>
+          <a:p>
+            <a:pPr>
+              <a:spcAft>
+                <a:spcPts val="600"/>
+              </a:spcAft>
+              <a:defRPr sz="1600" b="1">
+                <a:solidFill>
+                  <a:srgbClr val="21D8A0"/>
+                </a:solidFill>
+              </a:defRPr>
+            </a:pPr>
+            <a:r>
+              <a:t>Game &amp; Spatial Eng.</a:t>
+            </a:r>
+          </a:p>
+          <a:p>
+            <a:pPr>
+              <a:defRPr sz="1300">
+                <a:solidFill>
+                  <a:srgbClr val="A3B8B0"/>
+                </a:solidFill>
+              </a:defRPr>
+            </a:pPr>
+            <a:r>
+              <a:t>$10,000 (20%)</a:t>
+            </a:r>
+          </a:p>
+        </p:txBody>
+      </p:sp>
+      <p:sp>
+        <p:nvSpPr>
+          <p:cNvPr id="9" name="Rounded Rectangle 8"/>
+          <p:cNvSpPr/>
+          <p:nvPr/>
+        </p:nvSpPr>
+        <p:spPr>
+          <a:xfrm>
+            <a:off x="731520" y="4023360"/>
+            <a:ext cx="3291840" cy="2011680"/>
+          </a:xfrm>
+          <a:prstGeom prst="roundRect">
+            <a:avLst/>
+          </a:prstGeom>
+          <a:solidFill>
+            <a:srgbClr val="12241E"/>
+          </a:solidFill>
+          <a:ln w="19050">
+            <a:solidFill>
+              <a:srgbClr val="21D8A0"/>
+            </a:solidFill>
+          </a:ln>
+        </p:spPr>
+        <p:style>
+          <a:lnRef idx="1">
+            <a:schemeClr val="accent1"/>
+          </a:lnRef>
+          <a:fillRef idx="3">
+            <a:schemeClr val="accent1"/>
+          </a:fillRef>
+          <a:effectRef idx="2">
+            <a:schemeClr val="accent1"/>
+          </a:effectRef>
+          <a:fontRef idx="minor">
+            <a:schemeClr val="lt1"/>
+          </a:fontRef>
+        </p:style>
+        <p:txBody>
+          <a:bodyPr rtlCol="0" anchor="ctr"/>
+          <a:lstStyle/>
+          <a:p>
+            <a:pPr algn="ctr"/>
+          </a:p>
+        </p:txBody>
+      </p:sp>
+      <p:sp>
+        <p:nvSpPr>
+          <p:cNvPr id="10" name="TextBox 9"/>
+          <p:cNvSpPr txBox="1"/>
+          <p:nvPr/>
+        </p:nvSpPr>
+        <p:spPr>
+          <a:xfrm>
+            <a:off x="868680" y="4160520"/>
+            <a:ext cx="3017520" cy="1737360"/>
+          </a:xfrm>
+          <a:prstGeom prst="rect">
+            <a:avLst/>
+          </a:prstGeom>
+          <a:noFill/>
+        </p:spPr>
+        <p:txBody>
+          <a:bodyPr wrap="square">
+            <a:spAutoFit/>
+          </a:bodyPr>
+          <a:lstStyle/>
+          <a:p>
+            <a:pPr>
+              <a:spcAft>
+                <a:spcPts val="600"/>
+              </a:spcAft>
+              <a:defRPr sz="1600" b="1">
+                <a:solidFill>
+                  <a:srgbClr val="21D8A0"/>
+                </a:solidFill>
+              </a:defRPr>
+            </a:pPr>
+            <a:r>
+              <a:t>Brand &amp; Design</a:t>
+            </a:r>
+          </a:p>
+          <a:p>
+            <a:pPr>
+              <a:defRPr sz="1300">
+                <a:solidFill>
+                  <a:srgbClr val="A3B8B0"/>
+                </a:solidFill>
+              </a:defRPr>
+            </a:pPr>
+            <a:r>
+              <a:t>$6,000 (12%)</a:t>
+            </a:r>
+          </a:p>
+        </p:txBody>
+      </p:sp>
+      <p:sp>
+        <p:nvSpPr>
+          <p:cNvPr id="11" name="Rounded Rectangle 10"/>
+          <p:cNvSpPr/>
+          <p:nvPr/>
+        </p:nvSpPr>
+        <p:spPr>
+          <a:xfrm>
+            <a:off x="4389120" y="4023360"/>
+            <a:ext cx="3291840" cy="2011680"/>
+          </a:xfrm>
+          <a:prstGeom prst="roundRect">
+            <a:avLst/>
+          </a:prstGeom>
+          <a:solidFill>
+            <a:srgbClr val="12241E"/>
+          </a:solidFill>
+          <a:ln w="19050">
+            <a:solidFill>
+              <a:srgbClr val="21D8A0"/>
+            </a:solidFill>
+          </a:ln>
+        </p:spPr>
+        <p:style>
+          <a:lnRef idx="1">
+            <a:schemeClr val="accent1"/>
+          </a:lnRef>
+          <a:fillRef idx="3">
+            <a:schemeClr val="accent1"/>
+          </a:fillRef>
+          <a:effectRef idx="2">
+            <a:schemeClr val="accent1"/>
+          </a:effectRef>
+          <a:fontRef idx="minor">
+            <a:schemeClr val="lt1"/>
+          </a:fontRef>
+        </p:style>
+        <p:txBody>
+          <a:bodyPr rtlCol="0" anchor="ctr"/>
+          <a:lstStyle/>
+          <a:p>
+            <a:pPr algn="ctr"/>
+          </a:p>
+        </p:txBody>
+      </p:sp>
+      <p:sp>
+        <p:nvSpPr>
+          <p:cNvPr id="12" name="TextBox 11"/>
+          <p:cNvSpPr txBox="1"/>
+          <p:nvPr/>
+        </p:nvSpPr>
+        <p:spPr>
+          <a:xfrm>
+            <a:off x="4526280" y="4160520"/>
+            <a:ext cx="3017520" cy="1737360"/>
+          </a:xfrm>
+          <a:prstGeom prst="rect">
+            <a:avLst/>
+          </a:prstGeom>
+          <a:noFill/>
+        </p:spPr>
+        <p:txBody>
+          <a:bodyPr wrap="square">
+            <a:spAutoFit/>
+          </a:bodyPr>
+          <a:lstStyle/>
+          <a:p>
+            <a:pPr>
+              <a:spcAft>
+                <a:spcPts val="600"/>
+              </a:spcAft>
+              <a:defRPr sz="1600" b="1">
+                <a:solidFill>
+                  <a:srgbClr val="21D8A0"/>
+                </a:solidFill>
+              </a:defRPr>
+            </a:pPr>
+            <a:r>
+              <a:t>Marketing &amp; Community</a:t>
+            </a:r>
+          </a:p>
+          <a:p>
+            <a:pPr>
+              <a:defRPr sz="1300">
+                <a:solidFill>
+                  <a:srgbClr val="A3B8B0"/>
+                </a:solidFill>
+              </a:defRPr>
+            </a:pPr>
+            <a:r>
+              <a:t>$7,000 (14%)</a:t>
+            </a:r>
+          </a:p>
+        </p:txBody>
+      </p:sp>
+      <p:sp>
+        <p:nvSpPr>
+          <p:cNvPr id="13" name="Rounded Rectangle 12"/>
+          <p:cNvSpPr/>
+          <p:nvPr/>
+        </p:nvSpPr>
+        <p:spPr>
+          <a:xfrm>
+            <a:off x="8046720" y="4023360"/>
+            <a:ext cx="3291840" cy="2011680"/>
+          </a:xfrm>
+          <a:prstGeom prst="roundRect">
+            <a:avLst/>
+          </a:prstGeom>
+          <a:solidFill>
+            <a:srgbClr val="12241E"/>
+          </a:solidFill>
+          <a:ln w="19050">
+            <a:solidFill>
+              <a:srgbClr val="FFB800"/>
+            </a:solidFill>
+          </a:ln>
+        </p:spPr>
+        <p:style>
+          <a:lnRef idx="1">
+            <a:schemeClr val="accent1"/>
+          </a:lnRef>
+          <a:fillRef idx="3">
+            <a:schemeClr val="accent1"/>
+          </a:fillRef>
+          <a:effectRef idx="2">
+            <a:schemeClr val="accent1"/>
+          </a:effectRef>
+          <a:fontRef idx="minor">
+            <a:schemeClr val="lt1"/>
+          </a:fontRef>
+        </p:style>
+        <p:txBody>
+          <a:bodyPr rtlCol="0" anchor="ctr"/>
+          <a:lstStyle/>
+          <a:p>
+            <a:pPr algn="ctr"/>
+          </a:p>
+        </p:txBody>
+      </p:sp>
+      <p:sp>
+        <p:nvSpPr>
+          <p:cNvPr id="14" name="TextBox 13"/>
+          <p:cNvSpPr txBox="1"/>
+          <p:nvPr/>
+        </p:nvSpPr>
+        <p:spPr>
+          <a:xfrm>
+            <a:off x="8183880" y="4160520"/>
+            <a:ext cx="3017520" cy="1737360"/>
+          </a:xfrm>
+          <a:prstGeom prst="rect">
+            <a:avLst/>
+          </a:prstGeom>
+          <a:noFill/>
+        </p:spPr>
+        <p:txBody>
+          <a:bodyPr wrap="square">
+            <a:spAutoFit/>
+          </a:bodyPr>
+          <a:lstStyle/>
+          <a:p>
+            <a:pPr>
+              <a:spcAft>
+                <a:spcPts val="600"/>
+              </a:spcAft>
+              <a:defRPr sz="1600" b="1">
                 <a:solidFill>
                   <a:srgbClr val="FFB800"/>
                 </a:solidFill>
               </a:defRPr>
             </a:pPr>
             <a:r>
-              <a:t>💼 Minimum Funding Ask: $50,000 USD (Pre-Seed)</a:t>
-            </a:r>
-          </a:p>
-          <a:p>
-            <a:pPr>
-              <a:defRPr sz="1500" b="1">
-                <a:solidFill>
-                  <a:srgbClr val="00E5FF"/>
-                </a:solidFill>
-              </a:defRPr>
-            </a:pPr>
-            <a:r>
-              <a:t>🚀 Web Engine Live &amp; Ready for Mobile APK Deployment</a:t>
+              <a:t>Server, Legal, Zaxira</a:t>
+            </a:r>
+          </a:p>
+          <a:p>
+            <a:pPr>
+              <a:defRPr sz="1300">
+                <a:solidFill>
+                  <a:srgbClr val="A3B8B0"/>
+                </a:solidFill>
+              </a:defRPr>
+            </a:pPr>
+            <a:r>
+              <a:t>$5,000 (10%)</a:t>
             </a:r>
           </a:p>
         </p:txBody>

</xml_diff>